<commit_message>
style: increase font sizes and rename core innovations slide to '创新点'
</commit_message>
<xml_diff>
--- a/presentation_light.pptx
+++ b/presentation_light.pptx
@@ -14,10 +14,9 @@
     <p:sldId id="262" r:id="rId8"/>
     <p:sldId id="263" r:id="rId9"/>
     <p:sldId id="264" r:id="rId10"/>
-    <p:sldId id="265" r:id="rId11"/>
   </p:sldIdLst>
   <p:notesMasterIdLst>
-    <p:notesMasterId r:id="rId12"/>
+    <p:notesMasterId r:id="rId11"/>
   </p:notesMasterIdLst>
   <p:sldSz cx="9144000" cy="5143500"/>
   <p:notesSz cx="5143500" cy="9144000"/>
@@ -535,94 +534,6 @@
             <a:fld id="{F7021451-1387-4CA6-816F-3879F97B5CBC}" type="slidenum">
               <a:rPr lang="en-US"/>
               <a:t>1</a:t>
-            </a:fld>
-            <a:endParaRPr lang="en-US"/>
-          </a:p>
-        </p:txBody>
-      </p:sp>
-    </p:spTree>
-    <p:extLst>
-      <p:ext uri="{BB962C8B-B14F-4D97-AF65-F5344CB8AC3E}">
-        <p14:creationId xmlns:p14="http://schemas.microsoft.com/office/powerpoint/2010/main" val="1024086991"/>
-      </p:ext>
-    </p:extLst>
-  </p:cSld>
-  <p:clrMapOvr>
-    <a:masterClrMapping/>
-  </p:clrMapOvr>
-</p:notes>
-</file>
-
-<file path=ppt/notesSlides/notesSlide10.xml><?xml version="1.0" encoding="utf-8"?>
-<p:notes xmlns:a="http://schemas.openxmlformats.org/drawingml/2006/main" xmlns:r="http://schemas.openxmlformats.org/officeDocument/2006/relationships" xmlns:p="http://schemas.openxmlformats.org/presentationml/2006/main">
-  <p:cSld>
-    <p:spTree>
-      <p:nvGrpSpPr>
-        <p:cNvPr id="1" name=""/>
-        <p:cNvGrpSpPr/>
-        <p:nvPr/>
-      </p:nvGrpSpPr>
-      <p:grpSpPr>
-        <a:xfrm>
-          <a:off x="0" y="0"/>
-          <a:ext cx="0" cy="0"/>
-          <a:chOff x="0" y="0"/>
-          <a:chExt cx="0" cy="0"/>
-        </a:xfrm>
-      </p:grpSpPr>
-      <p:sp>
-        <p:nvSpPr>
-          <p:cNvPr id="2" name="Slide Image Placeholder 1"/>
-          <p:cNvSpPr>
-            <a:spLocks noGrp="1" noRot="1" noChangeAspect="1"/>
-          </p:cNvSpPr>
-          <p:nvPr>
-            <p:ph type="sldImg"/>
-          </p:nvPr>
-        </p:nvSpPr>
-        <p:spPr/>
-      </p:sp>
-      <p:sp>
-        <p:nvSpPr>
-          <p:cNvPr id="3" name="Notes Placeholder 2"/>
-          <p:cNvSpPr>
-            <a:spLocks noGrp="1"/>
-          </p:cNvSpPr>
-          <p:nvPr>
-            <p:ph type="body" idx="1"/>
-          </p:nvPr>
-        </p:nvSpPr>
-        <p:spPr/>
-        <p:txBody>
-          <a:bodyPr/>
-          <a:lstStyle/>
-          <a:p>
-            <a:r>
-              <a:rPr lang="en-US" dirty="0"/>
-              <a:t/>
-            </a:r>
-            <a:endParaRPr lang="en-US" dirty="0"/>
-          </a:p>
-        </p:txBody>
-      </p:sp>
-      <p:sp>
-        <p:nvSpPr>
-          <p:cNvPr id="4" name="Slide Number Placeholder 3"/>
-          <p:cNvSpPr>
-            <a:spLocks noGrp="1"/>
-          </p:cNvSpPr>
-          <p:nvPr>
-            <p:ph type="sldNum" sz="quarter" idx="10"/>
-          </p:nvPr>
-        </p:nvSpPr>
-        <p:spPr/>
-        <p:txBody>
-          <a:bodyPr/>
-          <a:lstStyle/>
-          <a:p>
-            <a:fld id="{F7021451-1387-4CA6-816F-3879F97B5CBC}" type="slidenum">
-              <a:rPr lang="en-US"/>
-              <a:t>10</a:t>
             </a:fld>
             <a:endParaRPr lang="en-US"/>
           </a:p>
@@ -1850,7 +1761,7 @@
                 <a:ea typeface="Microsoft YaHei" pitchFamily="34" charset="-122"/>
                 <a:cs typeface="Microsoft YaHei" pitchFamily="34" charset="-120"/>
               </a:rPr>
-              <a:t>答辩汇报人：云计算实验小组</a:t>
+              <a:t>答辩汇报人：严浩睿、霍秋明</a:t>
             </a:r>
             <a:endParaRPr lang="en-US" sz="1400" dirty="0"/>
           </a:p>
@@ -1871,175 +1782,6 @@
                 <a:cs typeface="Microsoft YaHei" pitchFamily="34" charset="-120"/>
               </a:rPr>
               <a:t>指导老师：课程答辩专家组</a:t>
-            </a:r>
-            <a:endParaRPr lang="en-US" sz="1400" dirty="0"/>
-          </a:p>
-        </p:txBody>
-      </p:sp>
-    </p:spTree>
-  </p:cSld>
-  <p:clrMapOvr>
-    <a:masterClrMapping/>
-  </p:clrMapOvr>
-</p:sld>
-</file>
-
-<file path=ppt/slides/slide10.xml><?xml version="1.0" encoding="utf-8"?>
-<p:sld xmlns:a="http://schemas.openxmlformats.org/drawingml/2006/main" xmlns:r="http://schemas.openxmlformats.org/officeDocument/2006/relationships" xmlns:p="http://schemas.openxmlformats.org/presentationml/2006/main">
-  <p:cSld name="Slide 10">
-    <p:bg>
-      <p:bgPr>
-        <a:solidFill>
-          <a:srgbClr val="F1F5F9"/>
-        </a:solidFill>
-      </p:bgPr>
-    </p:bg>
-    <p:spTree>
-      <p:nvGrpSpPr>
-        <p:cNvPr id="1" name=""/>
-        <p:cNvGrpSpPr/>
-        <p:nvPr/>
-      </p:nvGrpSpPr>
-      <p:grpSpPr>
-        <a:xfrm>
-          <a:off x="0" y="0"/>
-          <a:ext cx="0" cy="0"/>
-          <a:chOff x="0" y="0"/>
-          <a:chExt cx="0" cy="0"/>
-        </a:xfrm>
-      </p:grpSpPr>
-      <p:sp>
-        <p:nvSpPr>
-          <p:cNvPr id="2" name="Shape 0"/>
-          <p:cNvSpPr/>
-          <p:nvPr/>
-        </p:nvSpPr>
-        <p:spPr>
-          <a:xfrm>
-            <a:off x="0" y="3291840"/>
-            <a:ext cx="12188952" cy="274320"/>
-          </a:xfrm>
-          <a:prstGeom prst="rect">
-            <a:avLst/>
-          </a:prstGeom>
-          <a:solidFill>
-            <a:srgbClr val="0284C7"/>
-          </a:solidFill>
-          <a:ln/>
-        </p:spPr>
-      </p:sp>
-      <p:sp>
-        <p:nvSpPr>
-          <p:cNvPr id="3" name="Text 1"/>
-          <p:cNvSpPr/>
-          <p:nvPr/>
-        </p:nvSpPr>
-        <p:spPr>
-          <a:xfrm>
-            <a:off x="914400" y="1828800"/>
-            <a:ext cx="10360152" cy="914400"/>
-          </a:xfrm>
-          <a:prstGeom prst="rect">
-            <a:avLst/>
-          </a:prstGeom>
-          <a:noFill/>
-          <a:ln/>
-        </p:spPr>
-        <p:txBody>
-          <a:bodyPr wrap="square" rtlCol="0" anchor="ctr"/>
-          <a:lstStyle/>
-          <a:p>
-            <a:pPr algn="ctr" indent="0" marL="0">
-              <a:buNone/>
-            </a:pPr>
-            <a:r>
-              <a:rPr lang="en-US" sz="5400" b="1" dirty="0">
-                <a:solidFill>
-                  <a:srgbClr val="0284C7"/>
-                </a:solidFill>
-                <a:latin typeface="Trebuchet MS" pitchFamily="34" charset="0"/>
-                <a:ea typeface="Trebuchet MS" pitchFamily="34" charset="-122"/>
-                <a:cs typeface="Trebuchet MS" pitchFamily="34" charset="-120"/>
-              </a:rPr>
-              <a:t>THANK YOU</a:t>
-            </a:r>
-            <a:endParaRPr lang="en-US" sz="5400" dirty="0"/>
-          </a:p>
-        </p:txBody>
-      </p:sp>
-      <p:sp>
-        <p:nvSpPr>
-          <p:cNvPr id="4" name="Text 2"/>
-          <p:cNvSpPr/>
-          <p:nvPr/>
-        </p:nvSpPr>
-        <p:spPr>
-          <a:xfrm>
-            <a:off x="914400" y="3840480"/>
-            <a:ext cx="10360152" cy="731520"/>
-          </a:xfrm>
-          <a:prstGeom prst="rect">
-            <a:avLst/>
-          </a:prstGeom>
-          <a:noFill/>
-          <a:ln/>
-        </p:spPr>
-        <p:txBody>
-          <a:bodyPr wrap="square" rtlCol="0" anchor="ctr"/>
-          <a:lstStyle/>
-          <a:p>
-            <a:pPr algn="ctr" indent="0" marL="0">
-              <a:buNone/>
-            </a:pPr>
-            <a:r>
-              <a:rPr lang="en-US" sz="2400" b="1" dirty="0">
-                <a:solidFill>
-                  <a:srgbClr val="0F172A"/>
-                </a:solidFill>
-                <a:latin typeface="Microsoft YaHei" pitchFamily="34" charset="0"/>
-                <a:ea typeface="Microsoft YaHei" pitchFamily="34" charset="-122"/>
-                <a:cs typeface="Microsoft YaHei" pitchFamily="34" charset="-120"/>
-              </a:rPr>
-              <a:t>敬请各位老师、专家批评指正！</a:t>
-            </a:r>
-            <a:endParaRPr lang="en-US" sz="2400" dirty="0"/>
-          </a:p>
-        </p:txBody>
-      </p:sp>
-      <p:sp>
-        <p:nvSpPr>
-          <p:cNvPr id="5" name="Text 3"/>
-          <p:cNvSpPr/>
-          <p:nvPr/>
-        </p:nvSpPr>
-        <p:spPr>
-          <a:xfrm>
-            <a:off x="914400" y="4754880"/>
-            <a:ext cx="10360152" cy="548640"/>
-          </a:xfrm>
-          <a:prstGeom prst="rect">
-            <a:avLst/>
-          </a:prstGeom>
-          <a:noFill/>
-          <a:ln/>
-        </p:spPr>
-        <p:txBody>
-          <a:bodyPr wrap="square" rtlCol="0" anchor="ctr"/>
-          <a:lstStyle/>
-          <a:p>
-            <a:pPr algn="ctr" indent="0" marL="0">
-              <a:buNone/>
-            </a:pPr>
-            <a:r>
-              <a:rPr lang="en-US" sz="1400" dirty="0">
-                <a:solidFill>
-                  <a:srgbClr val="475569"/>
-                </a:solidFill>
-                <a:latin typeface="Microsoft YaHei" pitchFamily="34" charset="0"/>
-                <a:ea typeface="Microsoft YaHei" pitchFamily="34" charset="-122"/>
-                <a:cs typeface="Microsoft YaHei" pitchFamily="34" charset="-120"/>
-              </a:rPr>
-              <a:t>Chaos Fire Drill 项目开发小组 | 云计算与微服务大作业答辩</a:t>
             </a:r>
             <a:endParaRPr lang="en-US" sz="1400" dirty="0"/>
           </a:p>
@@ -2663,7 +2405,7 @@
                 <a:ea typeface="Microsoft YaHei" pitchFamily="34" charset="-122"/>
                 <a:cs typeface="Microsoft YaHei" pitchFamily="34" charset="-120"/>
               </a:rPr>
-              <a:t>2. 课程实验之间的深度联动与集大成</a:t>
+              <a:t>2. 课程微服务实验集大成联动</a:t>
             </a:r>
             <a:endParaRPr lang="en-US" sz="2600" dirty="0"/>
           </a:p>
@@ -3080,7 +2822,7 @@
                 <a:ea typeface="Microsoft YaHei" pitchFamily="34" charset="-122"/>
                 <a:cs typeface="Microsoft YaHei" pitchFamily="34" charset="-120"/>
               </a:rPr>
-              <a:t>提供合法受控的终端代理。利用物理沙箱环境在 live 集群上安全执行各种自愈指令。</a:t>
+              <a:t>提供合法受控的终端代理。利用物理沙箱环境在 live集群上安全执行各种自愈指令。</a:t>
             </a:r>
             <a:endParaRPr lang="en-US" sz="1250" dirty="0"/>
           </a:p>
@@ -4210,7 +3952,7 @@
                 <a:ea typeface="Microsoft YaHei" pitchFamily="34" charset="-122"/>
                 <a:cs typeface="Microsoft YaHei" pitchFamily="34" charset="-120"/>
               </a:rPr>
-              <a:t>4. 云计算创新点：纯生 K8s-Native 沙箱与轻量化故障</a:t>
+              <a:t>4. 创新点</a:t>
             </a:r>
             <a:endParaRPr lang="en-US" sz="2600" dirty="0"/>
           </a:p>
@@ -4249,7 +3991,7 @@
                 <a:ea typeface="Microsoft YaHei" pitchFamily="34" charset="-122"/>
                 <a:cs typeface="Microsoft YaHei" pitchFamily="34" charset="-120"/>
               </a:rPr>
-              <a:t>CLOUD COMPUTING INNOVATIONS &amp; LIVE SANDBOX</a:t>
+              <a:t>PROJECT CORE TECHNICAL INNOVATIONS</a:t>
             </a:r>
             <a:endParaRPr lang="en-US" sz="1200" dirty="0"/>
           </a:p>
@@ -4322,8 +4064,8 @@
         </p:nvSpPr>
         <p:spPr>
           <a:xfrm>
-            <a:off x="548640" y="1463040"/>
-            <a:ext cx="5303520" cy="4663440"/>
+            <a:off x="548640" y="1645920"/>
+            <a:ext cx="2560320" cy="4480560"/>
           </a:xfrm>
           <a:prstGeom prst="roundRect">
             <a:avLst/>
@@ -4347,8 +4089,8 @@
         </p:nvSpPr>
         <p:spPr>
           <a:xfrm>
-            <a:off x="822960" y="1645920"/>
-            <a:ext cx="4754880" cy="4297680"/>
+            <a:off x="731520" y="1828800"/>
+            <a:ext cx="2194560" cy="4114800"/>
           </a:xfrm>
           <a:prstGeom prst="rect">
             <a:avLst/>
@@ -4362,12 +4104,12 @@
           <a:p>
             <a:pPr indent="0" marL="0">
               <a:lnSpc>
-                <a:spcPts val="1800"/>
-              </a:lnSpc>
-              <a:buNone/>
-            </a:pPr>
-            <a:r>
-              <a:rPr lang="en-US" sz="1800" b="1" dirty="0">
+                <a:spcPts val="1400"/>
+              </a:lnSpc>
+              <a:buNone/>
+            </a:pPr>
+            <a:r>
+              <a:rPr lang="en-US" sz="1500" b="1" dirty="0">
                 <a:solidFill>
                   <a:srgbClr val="0284C7"/>
                 </a:solidFill>
@@ -4375,17 +4117,18 @@
                 <a:ea typeface="Microsoft YaHei" pitchFamily="34" charset="-122"/>
                 <a:cs typeface="Microsoft YaHei" pitchFamily="34" charset="-120"/>
               </a:rPr>
-              <a:t>☸️ Kubernetes-Native 真实集群穿透
+              <a:t>☸️ K8s-Native
+物理注入自愈
 </a:t>
             </a:r>
             <a:pPr indent="0" marL="0">
               <a:lnSpc>
-                <a:spcPts val="1800"/>
-              </a:lnSpc>
-              <a:buNone/>
-            </a:pPr>
-            <a:r>
-              <a:rPr lang="en-US" sz="1250" b="1" dirty="0">
+                <a:spcPts val="1400"/>
+              </a:lnSpc>
+              <a:buNone/>
+            </a:pPr>
+            <a:r>
+              <a:rPr lang="en-US" sz="1150" b="1" dirty="0">
                 <a:solidFill>
                   <a:srgbClr val="0F172A"/>
                 </a:solidFill>
@@ -4393,16 +4136,16 @@
                 <a:ea typeface="Microsoft YaHei" pitchFamily="34" charset="-122"/>
                 <a:cs typeface="Microsoft YaHei" pitchFamily="34" charset="-120"/>
               </a:rPr>
-              <a:t>• 彻底摒弃伪模拟 (Fake Mock)：</a:t>
-            </a:r>
-            <a:pPr indent="0" marL="0">
-              <a:lnSpc>
-                <a:spcPts val="1800"/>
-              </a:lnSpc>
-              <a:buNone/>
-            </a:pPr>
-            <a:r>
-              <a:rPr lang="en-US" sz="1250" dirty="0">
+              <a:t>• 物理集群穿透：</a:t>
+            </a:r>
+            <a:pPr indent="0" marL="0">
+              <a:lnSpc>
+                <a:spcPts val="1400"/>
+              </a:lnSpc>
+              <a:buNone/>
+            </a:pPr>
+            <a:r>
+              <a:rPr lang="en-US" sz="1150" dirty="0">
                 <a:solidFill>
                   <a:srgbClr val="475569"/>
                 </a:solidFill>
@@ -4410,17 +4153,17 @@
                 <a:ea typeface="Microsoft YaHei" pitchFamily="34" charset="-122"/>
                 <a:cs typeface="Microsoft YaHei" pitchFamily="34" charset="-120"/>
               </a:rPr>
-              <a:t>绝非纸面逻辑模拟，每一次在大屏上观察到的指标振荡、Pod 死亡与重建，都是对真实容器状态的反射。
+              <a:t>每一次指标反馈直接作用于物理容器节点。
 </a:t>
             </a:r>
             <a:pPr indent="0" marL="0">
               <a:lnSpc>
-                <a:spcPts val="1800"/>
-              </a:lnSpc>
-              <a:buNone/>
-            </a:pPr>
-            <a:r>
-              <a:rPr lang="en-US" sz="1250" b="1" dirty="0">
+                <a:spcPts val="1400"/>
+              </a:lnSpc>
+              <a:buNone/>
+            </a:pPr>
+            <a:r>
+              <a:rPr lang="en-US" sz="1150" b="1" dirty="0">
                 <a:solidFill>
                   <a:srgbClr val="0F172A"/>
                 </a:solidFill>
@@ -4428,16 +4171,16 @@
                 <a:ea typeface="Microsoft YaHei" pitchFamily="34" charset="-122"/>
                 <a:cs typeface="Microsoft YaHei" pitchFamily="34" charset="-120"/>
               </a:rPr>
-              <a:t>• 轻量级原生故障注入：</a:t>
-            </a:r>
-            <a:pPr indent="0" marL="0">
-              <a:lnSpc>
-                <a:spcPts val="1800"/>
-              </a:lnSpc>
-              <a:buNone/>
-            </a:pPr>
-            <a:r>
-              <a:rPr lang="en-US" sz="1250" dirty="0">
+              <a:t>• 轻量故障注入：</a:t>
+            </a:r>
+            <a:pPr indent="0" marL="0">
+              <a:lnSpc>
+                <a:spcPts val="1400"/>
+              </a:lnSpc>
+              <a:buNone/>
+            </a:pPr>
+            <a:r>
+              <a:rPr lang="en-US" sz="1150" dirty="0">
                 <a:solidFill>
                   <a:srgbClr val="475569"/>
                 </a:solidFill>
@@ -4445,17 +4188,17 @@
                 <a:ea typeface="Microsoft YaHei" pitchFamily="34" charset="-122"/>
                 <a:cs typeface="Microsoft YaHei" pitchFamily="34" charset="-120"/>
               </a:rPr>
-              <a:t>不引入重型混沌框架，使用内置 TC Netem 制造高逼真网络抖动、使用 dd 读写模拟磁盘满仓，直观再现级联雪崩。
+              <a:t>不部署重型平面，使用原生 TC Netem 及 dd 搞定故障。
 </a:t>
             </a:r>
             <a:pPr indent="0" marL="0">
               <a:lnSpc>
-                <a:spcPts val="1800"/>
-              </a:lnSpc>
-              <a:buNone/>
-            </a:pPr>
-            <a:r>
-              <a:rPr lang="en-US" sz="1250" b="1" dirty="0">
+                <a:spcPts val="1400"/>
+              </a:lnSpc>
+              <a:buNone/>
+            </a:pPr>
+            <a:r>
+              <a:rPr lang="en-US" sz="1150" b="1" dirty="0">
                 <a:solidFill>
                   <a:srgbClr val="0F172A"/>
                 </a:solidFill>
@@ -4463,16 +4206,16 @@
                 <a:ea typeface="Microsoft YaHei" pitchFamily="34" charset="-122"/>
                 <a:cs typeface="Microsoft YaHei" pitchFamily="34" charset="-120"/>
               </a:rPr>
-              <a:t>• 自动调谐回滚：</a:t>
-            </a:r>
-            <a:pPr indent="0" marL="0">
-              <a:lnSpc>
-                <a:spcPts val="1800"/>
-              </a:lnSpc>
-              <a:buNone/>
-            </a:pPr>
-            <a:r>
-              <a:rPr lang="en-US" sz="1250" dirty="0">
+              <a:t>• 秒级清理回滚：</a:t>
+            </a:r>
+            <a:pPr indent="0" marL="0">
+              <a:lnSpc>
+                <a:spcPts val="1400"/>
+              </a:lnSpc>
+              <a:buNone/>
+            </a:pPr>
+            <a:r>
+              <a:rPr lang="en-US" sz="1150" dirty="0">
                 <a:solidFill>
                   <a:srgbClr val="475569"/>
                 </a:solidFill>
@@ -4480,9 +4223,9 @@
                 <a:ea typeface="Microsoft YaHei" pitchFamily="34" charset="-122"/>
                 <a:cs typeface="Microsoft YaHei" pitchFamily="34" charset="-120"/>
               </a:rPr>
-              <a:t>若演习超时或退赛，后端自愈协程秒级触发 restoreFn，全量清理所有注入故障，维持靶场无残留洁净状态。</a:t>
-            </a:r>
-            <a:endParaRPr lang="en-US" sz="1250" dirty="0"/>
+              <a:t>退赛或超时秒级回滚，维持物理靶场洁净无残留。</a:t>
+            </a:r>
+            <a:endParaRPr lang="en-US" sz="1150" dirty="0"/>
           </a:p>
         </p:txBody>
       </p:sp>
@@ -4494,8 +4237,8 @@
         </p:nvSpPr>
         <p:spPr>
           <a:xfrm>
-            <a:off x="6309360" y="1463040"/>
-            <a:ext cx="5303520" cy="4663440"/>
+            <a:off x="3383280" y="1645920"/>
+            <a:ext cx="2560320" cy="4480560"/>
           </a:xfrm>
           <a:prstGeom prst="roundRect">
             <a:avLst/>
@@ -4519,8 +4262,8 @@
         </p:nvSpPr>
         <p:spPr>
           <a:xfrm>
-            <a:off x="6583680" y="1645920"/>
-            <a:ext cx="4754880" cy="4297680"/>
+            <a:off x="3566160" y="1828800"/>
+            <a:ext cx="2194560" cy="4114800"/>
           </a:xfrm>
           <a:prstGeom prst="rect">
             <a:avLst/>
@@ -4534,12 +4277,12 @@
           <a:p>
             <a:pPr indent="0" marL="0">
               <a:lnSpc>
-                <a:spcPts val="1800"/>
-              </a:lnSpc>
-              <a:buNone/>
-            </a:pPr>
-            <a:r>
-              <a:rPr lang="en-US" sz="1800" b="1" dirty="0">
+                <a:spcPts val="1400"/>
+              </a:lnSpc>
+              <a:buNone/>
+            </a:pPr>
+            <a:r>
+              <a:rPr lang="en-US" sz="1500" b="1" dirty="0">
                 <a:solidFill>
                   <a:srgbClr val="10B981"/>
                 </a:solidFill>
@@ -4547,17 +4290,18 @@
                 <a:ea typeface="Microsoft YaHei" pitchFamily="34" charset="-122"/>
                 <a:cs typeface="Microsoft YaHei" pitchFamily="34" charset="-120"/>
               </a:rPr>
-              <a:t>🔒 安全命令重写网关 (Terminal Proxy)
+              <a:t>🔒 安全代理
+命令重写沙箱
 </a:t>
             </a:r>
             <a:pPr indent="0" marL="0">
               <a:lnSpc>
-                <a:spcPts val="1800"/>
-              </a:lnSpc>
-              <a:buNone/>
-            </a:pPr>
-            <a:r>
-              <a:rPr lang="en-US" sz="1250" b="1" dirty="0">
+                <a:spcPts val="1400"/>
+              </a:lnSpc>
+              <a:buNone/>
+            </a:pPr>
+            <a:r>
+              <a:rPr lang="en-US" sz="1150" b="1" dirty="0">
                 <a:solidFill>
                   <a:srgbClr val="0F172A"/>
                 </a:solidFill>
@@ -4565,16 +4309,16 @@
                 <a:ea typeface="Microsoft YaHei" pitchFamily="34" charset="-122"/>
                 <a:cs typeface="Microsoft YaHei" pitchFamily="34" charset="-120"/>
               </a:rPr>
-              <a:t>• 多租户逻辑沙箱隔离：</a:t>
-            </a:r>
-            <a:pPr indent="0" marL="0">
-              <a:lnSpc>
-                <a:spcPts val="1800"/>
-              </a:lnSpc>
-              <a:buNone/>
-            </a:pPr>
-            <a:r>
-              <a:rPr lang="en-US" sz="1250" dirty="0">
+              <a:t>• 命名空间锁定：</a:t>
+            </a:r>
+            <a:pPr indent="0" marL="0">
+              <a:lnSpc>
+                <a:spcPts val="1400"/>
+              </a:lnSpc>
+              <a:buNone/>
+            </a:pPr>
+            <a:r>
+              <a:rPr lang="en-US" sz="1150" dirty="0">
                 <a:solidFill>
                   <a:srgbClr val="475569"/>
                 </a:solidFill>
@@ -4582,17 +4326,17 @@
                 <a:ea typeface="Microsoft YaHei" pitchFamily="34" charset="-122"/>
                 <a:cs typeface="Microsoft YaHei" pitchFamily="34" charset="-120"/>
               </a:rPr>
-              <a:t>对所有前台人类输入指令实施正则重写。强制替换并追加 `-n &lt;current-namespace&gt;` 参数，彻底封锁越权删除系统级命名空间的隐患。
+              <a:t>前台指令通过正则拦截，动态追加并重写替换命名空间。
 </a:t>
             </a:r>
             <a:pPr indent="0" marL="0">
               <a:lnSpc>
-                <a:spcPts val="1800"/>
-              </a:lnSpc>
-              <a:buNone/>
-            </a:pPr>
-            <a:r>
-              <a:rPr lang="en-US" sz="1250" b="1" dirty="0">
+                <a:spcPts val="1400"/>
+              </a:lnSpc>
+              <a:buNone/>
+            </a:pPr>
+            <a:r>
+              <a:rPr lang="en-US" sz="1150" b="1" dirty="0">
                 <a:solidFill>
                   <a:srgbClr val="0F172A"/>
                 </a:solidFill>
@@ -4600,16 +4344,16 @@
                 <a:ea typeface="Microsoft YaHei" pitchFamily="34" charset="-122"/>
                 <a:cs typeface="Microsoft YaHei" pitchFamily="34" charset="-120"/>
               </a:rPr>
-              <a:t>• 静态白名单硬拦截：</a:t>
-            </a:r>
-            <a:pPr indent="0" marL="0">
-              <a:lnSpc>
-                <a:spcPts val="1800"/>
-              </a:lnSpc>
-              <a:buNone/>
-            </a:pPr>
-            <a:r>
-              <a:rPr lang="en-US" sz="1250" dirty="0">
+              <a:t>• 静态白名单限制：</a:t>
+            </a:r>
+            <a:pPr indent="0" marL="0">
+              <a:lnSpc>
+                <a:spcPts val="1400"/>
+              </a:lnSpc>
+              <a:buNone/>
+            </a:pPr>
+            <a:r>
+              <a:rPr lang="en-US" sz="1150" dirty="0">
                 <a:solidFill>
                   <a:srgbClr val="475569"/>
                 </a:solidFill>
@@ -4617,17 +4361,17 @@
                 <a:ea typeface="Microsoft YaHei" pitchFamily="34" charset="-122"/>
                 <a:cs typeface="Microsoft YaHei" pitchFamily="34" charset="-120"/>
               </a:rPr>
-              <a:t>严格限制前台执行 `kubectl get`, `kubectl logs`, `kubectl describe`, `kubectl scale`, `kubectl rollout`, `kubectl exec` 等 6 类核心观测命令。
+              <a:t>严格仅允许 logs、describe 等 6 种安全可观测指令。
 </a:t>
             </a:r>
             <a:pPr indent="0" marL="0">
               <a:lnSpc>
-                <a:spcPts val="1800"/>
-              </a:lnSpc>
-              <a:buNone/>
-            </a:pPr>
-            <a:r>
-              <a:rPr lang="en-US" sz="1250" b="1" dirty="0">
+                <a:spcPts val="1400"/>
+              </a:lnSpc>
+              <a:buNone/>
+            </a:pPr>
+            <a:r>
+              <a:rPr lang="en-US" sz="1150" b="1" dirty="0">
                 <a:solidFill>
                   <a:srgbClr val="0F172A"/>
                 </a:solidFill>
@@ -4635,16 +4379,16 @@
                 <a:ea typeface="Microsoft YaHei" pitchFamily="34" charset="-122"/>
                 <a:cs typeface="Microsoft YaHei" pitchFamily="34" charset="-120"/>
               </a:rPr>
-              <a:t>• 拼接逃逸过滤：</a:t>
-            </a:r>
-            <a:pPr indent="0" marL="0">
-              <a:lnSpc>
-                <a:spcPts val="1800"/>
-              </a:lnSpc>
-              <a:buNone/>
-            </a:pPr>
-            <a:r>
-              <a:rPr lang="en-US" sz="1250" dirty="0">
+              <a:t>• 防拼接逃逸：</a:t>
+            </a:r>
+            <a:pPr indent="0" marL="0">
+              <a:lnSpc>
+                <a:spcPts val="1400"/>
+              </a:lnSpc>
+              <a:buNone/>
+            </a:pPr>
+            <a:r>
+              <a:rPr lang="en-US" sz="1150" dirty="0">
                 <a:solidFill>
                   <a:srgbClr val="475569"/>
                 </a:solidFill>
@@ -4652,9 +4396,355 @@
                 <a:ea typeface="Microsoft YaHei" pitchFamily="34" charset="-122"/>
                 <a:cs typeface="Microsoft YaHei" pitchFamily="34" charset="-120"/>
               </a:rPr>
-              <a:t>物理阻断分号、后台挂起、多重命令拼接，在开放运维自主权的同时实现极高等级的网络防御。</a:t>
-            </a:r>
-            <a:endParaRPr lang="en-US" sz="1250" dirty="0"/>
+              <a:t>物理阻断分号及多重后台挂起操作，锁死系统级风险。</a:t>
+            </a:r>
+            <a:endParaRPr lang="en-US" sz="1150" dirty="0"/>
+          </a:p>
+        </p:txBody>
+      </p:sp>
+      <p:sp>
+        <p:nvSpPr>
+          <p:cNvPr id="11" name="Shape 9"/>
+          <p:cNvSpPr/>
+          <p:nvPr/>
+        </p:nvSpPr>
+        <p:spPr>
+          <a:xfrm>
+            <a:off x="6217920" y="1645920"/>
+            <a:ext cx="2560320" cy="4480560"/>
+          </a:xfrm>
+          <a:prstGeom prst="roundRect">
+            <a:avLst/>
+          </a:prstGeom>
+          <a:solidFill>
+            <a:srgbClr val="FFFFFF"/>
+          </a:solidFill>
+          <a:ln w="12700">
+            <a:solidFill>
+              <a:srgbClr val="E2E8F0"/>
+            </a:solidFill>
+            <a:prstDash val="solid"/>
+          </a:ln>
+        </p:spPr>
+      </p:sp>
+      <p:sp>
+        <p:nvSpPr>
+          <p:cNvPr id="12" name="Text 10"/>
+          <p:cNvSpPr/>
+          <p:nvPr/>
+        </p:nvSpPr>
+        <p:spPr>
+          <a:xfrm>
+            <a:off x="6400800" y="1828800"/>
+            <a:ext cx="2194560" cy="4114800"/>
+          </a:xfrm>
+          <a:prstGeom prst="rect">
+            <a:avLst/>
+          </a:prstGeom>
+          <a:noFill/>
+          <a:ln/>
+        </p:spPr>
+        <p:txBody>
+          <a:bodyPr wrap="square" rtlCol="0" anchor="ctr"/>
+          <a:lstStyle/>
+          <a:p>
+            <a:pPr indent="0" marL="0">
+              <a:lnSpc>
+                <a:spcPts val="1400"/>
+              </a:lnSpc>
+              <a:buNone/>
+            </a:pPr>
+            <a:r>
+              <a:rPr lang="en-US" sz="1500" b="1" dirty="0">
+                <a:solidFill>
+                  <a:srgbClr val="0284C7"/>
+                </a:solidFill>
+                <a:latin typeface="Microsoft YaHei" pitchFamily="34" charset="0"/>
+                <a:ea typeface="Microsoft YaHei" pitchFamily="34" charset="-122"/>
+                <a:cs typeface="Microsoft YaHei" pitchFamily="34" charset="-120"/>
+              </a:rPr>
+              <a:t>🔍 快照剪枝
+对比降噪算法
+</a:t>
+            </a:r>
+            <a:pPr indent="0" marL="0">
+              <a:lnSpc>
+                <a:spcPts val="1400"/>
+              </a:lnSpc>
+              <a:buNone/>
+            </a:pPr>
+            <a:r>
+              <a:rPr lang="en-US" sz="1150" b="1" dirty="0">
+                <a:solidFill>
+                  <a:srgbClr val="0F172A"/>
+                </a:solidFill>
+                <a:latin typeface="Microsoft YaHei" pitchFamily="34" charset="0"/>
+                <a:ea typeface="Microsoft YaHei" pitchFamily="34" charset="-122"/>
+                <a:cs typeface="Microsoft YaHei" pitchFamily="34" charset="-120"/>
+              </a:rPr>
+              <a:t>• 突破日志噪声：</a:t>
+            </a:r>
+            <a:pPr indent="0" marL="0">
+              <a:lnSpc>
+                <a:spcPts val="1400"/>
+              </a:lnSpc>
+              <a:buNone/>
+            </a:pPr>
+            <a:r>
+              <a:rPr lang="en-US" sz="1150" dirty="0">
+                <a:solidFill>
+                  <a:srgbClr val="475569"/>
+                </a:solidFill>
+                <a:latin typeface="Microsoft YaHei" pitchFamily="34" charset="0"/>
+                <a:ea typeface="Microsoft YaHei" pitchFamily="34" charset="-122"/>
+                <a:cs typeface="Microsoft YaHei" pitchFamily="34" charset="-120"/>
+              </a:rPr>
+              <a:t>海量元数据极易导致 LLM “注意力迷失”并消耗大量费用。
+</a:t>
+            </a:r>
+            <a:pPr indent="0" marL="0">
+              <a:lnSpc>
+                <a:spcPts val="1400"/>
+              </a:lnSpc>
+              <a:buNone/>
+            </a:pPr>
+            <a:r>
+              <a:rPr lang="en-US" sz="1150" b="1" dirty="0">
+                <a:solidFill>
+                  <a:srgbClr val="0F172A"/>
+                </a:solidFill>
+                <a:latin typeface="Microsoft YaHei" pitchFamily="34" charset="0"/>
+                <a:ea typeface="Microsoft YaHei" pitchFamily="34" charset="-122"/>
+                <a:cs typeface="Microsoft YaHei" pitchFamily="34" charset="-120"/>
+              </a:rPr>
+              <a:t>• 黄金基线比对：</a:t>
+            </a:r>
+            <a:pPr indent="0" marL="0">
+              <a:lnSpc>
+                <a:spcPts val="1400"/>
+              </a:lnSpc>
+              <a:buNone/>
+            </a:pPr>
+            <a:r>
+              <a:rPr lang="en-US" sz="1150" dirty="0">
+                <a:solidFill>
+                  <a:srgbClr val="475569"/>
+                </a:solidFill>
+                <a:latin typeface="Microsoft YaHei" pitchFamily="34" charset="0"/>
+                <a:ea typeface="Microsoft YaHei" pitchFamily="34" charset="-122"/>
+                <a:cs typeface="Microsoft YaHei" pitchFamily="34" charset="-120"/>
+              </a:rPr>
+              <a:t>定时拉取并与 Baseline 对比，剔除正常细节与长串UUID。
+</a:t>
+            </a:r>
+            <a:pPr indent="0" marL="0">
+              <a:lnSpc>
+                <a:spcPts val="1400"/>
+              </a:lnSpc>
+              <a:buNone/>
+            </a:pPr>
+            <a:r>
+              <a:rPr lang="en-US" sz="1150" b="1" dirty="0">
+                <a:solidFill>
+                  <a:srgbClr val="0F172A"/>
+                </a:solidFill>
+                <a:latin typeface="Microsoft YaHei" pitchFamily="34" charset="0"/>
+                <a:ea typeface="Microsoft YaHei" pitchFamily="34" charset="-122"/>
+                <a:cs typeface="Microsoft YaHei" pitchFamily="34" charset="-120"/>
+              </a:rPr>
+              <a:t>• 极限瘦身 75%：</a:t>
+            </a:r>
+            <a:pPr indent="0" marL="0">
+              <a:lnSpc>
+                <a:spcPts val="1400"/>
+              </a:lnSpc>
+              <a:buNone/>
+            </a:pPr>
+            <a:r>
+              <a:rPr lang="en-US" sz="1150" dirty="0">
+                <a:solidFill>
+                  <a:srgbClr val="475569"/>
+                </a:solidFill>
+                <a:latin typeface="Microsoft YaHei" pitchFamily="34" charset="0"/>
+                <a:ea typeface="Microsoft YaHei" pitchFamily="34" charset="-122"/>
+                <a:cs typeface="Microsoft YaHei" pitchFamily="34" charset="-120"/>
+              </a:rPr>
+              <a:t>仅向 LLM 喂入最高信噪比诊断快照，确保根因精确定位。</a:t>
+            </a:r>
+            <a:endParaRPr lang="en-US" sz="1150" dirty="0"/>
+          </a:p>
+        </p:txBody>
+      </p:sp>
+      <p:sp>
+        <p:nvSpPr>
+          <p:cNvPr id="13" name="Shape 11"/>
+          <p:cNvSpPr/>
+          <p:nvPr/>
+        </p:nvSpPr>
+        <p:spPr>
+          <a:xfrm>
+            <a:off x="9052560" y="1645920"/>
+            <a:ext cx="2560320" cy="4480560"/>
+          </a:xfrm>
+          <a:prstGeom prst="roundRect">
+            <a:avLst/>
+          </a:prstGeom>
+          <a:solidFill>
+            <a:srgbClr val="FFFFFF"/>
+          </a:solidFill>
+          <a:ln w="12700">
+            <a:solidFill>
+              <a:srgbClr val="E2E8F0"/>
+            </a:solidFill>
+            <a:prstDash val="solid"/>
+          </a:ln>
+        </p:spPr>
+      </p:sp>
+      <p:sp>
+        <p:nvSpPr>
+          <p:cNvPr id="14" name="Text 12"/>
+          <p:cNvSpPr/>
+          <p:nvPr/>
+        </p:nvSpPr>
+        <p:spPr>
+          <a:xfrm>
+            <a:off x="9235440" y="1828800"/>
+            <a:ext cx="2194560" cy="4114800"/>
+          </a:xfrm>
+          <a:prstGeom prst="rect">
+            <a:avLst/>
+          </a:prstGeom>
+          <a:noFill/>
+          <a:ln/>
+        </p:spPr>
+        <p:txBody>
+          <a:bodyPr wrap="square" rtlCol="0" anchor="ctr"/>
+          <a:lstStyle/>
+          <a:p>
+            <a:pPr indent="0" marL="0">
+              <a:lnSpc>
+                <a:spcPts val="1300"/>
+              </a:lnSpc>
+              <a:buNone/>
+            </a:pPr>
+            <a:r>
+              <a:rPr lang="en-US" sz="1500" b="1" dirty="0">
+                <a:solidFill>
+                  <a:srgbClr val="10B981"/>
+                </a:solidFill>
+                <a:latin typeface="Microsoft YaHei" pitchFamily="34" charset="0"/>
+                <a:ea typeface="Microsoft YaHei" pitchFamily="34" charset="-122"/>
+                <a:cs typeface="Microsoft YaHei" pitchFamily="34" charset="-120"/>
+              </a:rPr>
+              <a:t>🤖 OODA 循环
+全自愈智能体
+</a:t>
+            </a:r>
+            <a:pPr indent="0" marL="0">
+              <a:lnSpc>
+                <a:spcPts val="1300"/>
+              </a:lnSpc>
+              <a:buNone/>
+            </a:pPr>
+            <a:r>
+              <a:rPr lang="en-US" sz="1150" b="1" dirty="0">
+                <a:solidFill>
+                  <a:srgbClr val="0F172A"/>
+                </a:solidFill>
+                <a:latin typeface="Microsoft YaHei" pitchFamily="34" charset="0"/>
+                <a:ea typeface="Microsoft YaHei" pitchFamily="34" charset="-122"/>
+                <a:cs typeface="Microsoft YaHei" pitchFamily="34" charset="-120"/>
+              </a:rPr>
+              <a:t>• OODA 全闭环：</a:t>
+            </a:r>
+            <a:pPr indent="0" marL="0">
+              <a:lnSpc>
+                <a:spcPts val="1300"/>
+              </a:lnSpc>
+              <a:buNone/>
+            </a:pPr>
+            <a:r>
+              <a:rPr lang="en-US" sz="1150" dirty="0">
+                <a:solidFill>
+                  <a:srgbClr val="475569"/>
+                </a:solidFill>
+                <a:latin typeface="Microsoft YaHei" pitchFamily="34" charset="0"/>
+                <a:ea typeface="Microsoft YaHei" pitchFamily="34" charset="-122"/>
+                <a:cs typeface="Microsoft YaHei" pitchFamily="34" charset="-120"/>
+              </a:rPr>
+              <a:t>Observe 探测快照 $\rightarrow$ Orient 拓扑推理 $\rightarrow$ Decide 自愈决策 $\rightarrow$ Action 集群操作。
+</a:t>
+            </a:r>
+            <a:pPr indent="0" marL="0">
+              <a:lnSpc>
+                <a:spcPts val="1300"/>
+              </a:lnSpc>
+              <a:buNone/>
+            </a:pPr>
+            <a:r>
+              <a:rPr lang="en-US" sz="1150" b="1" dirty="0">
+                <a:solidFill>
+                  <a:srgbClr val="0F172A"/>
+                </a:solidFill>
+                <a:latin typeface="Microsoft YaHei" pitchFamily="34" charset="0"/>
+                <a:ea typeface="Microsoft YaHei" pitchFamily="34" charset="-122"/>
+                <a:cs typeface="Microsoft YaHei" pitchFamily="34" charset="-120"/>
+              </a:rPr>
+              <a:t>• 思维链推理：</a:t>
+            </a:r>
+            <a:pPr indent="0" marL="0">
+              <a:lnSpc>
+                <a:spcPts val="1300"/>
+              </a:lnSpc>
+              <a:buNone/>
+            </a:pPr>
+            <a:r>
+              <a:rPr lang="en-US" sz="1150" dirty="0">
+                <a:solidFill>
+                  <a:srgbClr val="475569"/>
+                </a:solidFill>
+                <a:latin typeface="Microsoft YaHei" pitchFamily="34" charset="0"/>
+                <a:ea typeface="Microsoft YaHei" pitchFamily="34" charset="-122"/>
+                <a:cs typeface="Microsoft YaHei" pitchFamily="34" charset="-120"/>
+              </a:rPr>
+              <a:t>推演过程白盒化。怀疑对象和自愈依据在前端大屏实时推流展示。
+</a:t>
+            </a:r>
+            <a:pPr indent="0" marL="0">
+              <a:lnSpc>
+                <a:spcPts val="1300"/>
+              </a:lnSpc>
+              <a:buNone/>
+            </a:pPr>
+            <a:r>
+              <a:rPr lang="en-US" sz="1150" b="1" dirty="0">
+                <a:solidFill>
+                  <a:srgbClr val="0F172A"/>
+                </a:solidFill>
+                <a:latin typeface="Microsoft YaHei" pitchFamily="34" charset="0"/>
+                <a:ea typeface="Microsoft YaHei" pitchFamily="34" charset="-122"/>
+                <a:cs typeface="Microsoft YaHei" pitchFamily="34" charset="-120"/>
+              </a:rPr>
+              <a:t>• 动作循环调谐：</a:t>
+            </a:r>
+            <a:pPr indent="0" marL="0">
+              <a:lnSpc>
+                <a:spcPts val="1300"/>
+              </a:lnSpc>
+              <a:buNone/>
+            </a:pPr>
+            <a:r>
+              <a:rPr lang="en-US" sz="1150" dirty="0">
+                <a:solidFill>
+                  <a:srgbClr val="475569"/>
+                </a:solidFill>
+                <a:latin typeface="Microsoft YaHei" pitchFamily="34" charset="0"/>
+                <a:ea typeface="Microsoft YaHei" pitchFamily="34" charset="-122"/>
+                <a:cs typeface="Microsoft YaHei" pitchFamily="34" charset="-120"/>
+              </a:rPr>
+              <a:t>智能下发自愈指令，循环迭代监控直到全集群健康自愈。</a:t>
+            </a:r>
+            <a:endParaRPr lang="en-US" sz="1150" dirty="0"/>
           </a:p>
         </p:txBody>
       </p:sp>
@@ -4743,7 +4833,7 @@
                 <a:ea typeface="Microsoft YaHei" pitchFamily="34" charset="-122"/>
                 <a:cs typeface="Microsoft YaHei" pitchFamily="34" charset="-120"/>
               </a:rPr>
-              <a:t>5. AI 创新点：DevOps Agent 与 OODA 自愈闭环</a:t>
+              <a:t>5. 严谨的评分标准与多维度量化体系</a:t>
             </a:r>
             <a:endParaRPr lang="en-US" sz="2600" dirty="0"/>
           </a:p>
@@ -4782,7 +4872,7 @@
                 <a:ea typeface="Microsoft YaHei" pitchFamily="34" charset="-122"/>
                 <a:cs typeface="Microsoft YaHei" pitchFamily="34" charset="-120"/>
               </a:rPr>
-              <a:t>AI INNOVATIONS &amp; OODA SELF-HEALING LOOP</a:t>
+              <a:t>SACS MULTI-DIMENSIONAL SCORING SYSTEM</a:t>
             </a:r>
             <a:endParaRPr lang="en-US" sz="1200" dirty="0"/>
           </a:p>
@@ -4849,14 +4939,53 @@
       </p:sp>
       <p:sp>
         <p:nvSpPr>
-          <p:cNvPr id="7" name="Shape 5"/>
-          <p:cNvSpPr/>
-          <p:nvPr/>
-        </p:nvSpPr>
-        <p:spPr>
-          <a:xfrm>
-            <a:off x="548640" y="1463040"/>
-            <a:ext cx="5303520" cy="4663440"/>
+          <p:cNvPr id="7" name="Text 5"/>
+          <p:cNvSpPr/>
+          <p:nvPr/>
+        </p:nvSpPr>
+        <p:spPr>
+          <a:xfrm>
+            <a:off x="548640" y="1280160"/>
+            <a:ext cx="10972800" cy="274320"/>
+          </a:xfrm>
+          <a:prstGeom prst="rect">
+            <a:avLst/>
+          </a:prstGeom>
+          <a:noFill/>
+          <a:ln/>
+        </p:spPr>
+        <p:txBody>
+          <a:bodyPr wrap="square" rtlCol="0" anchor="ctr"/>
+          <a:lstStyle/>
+          <a:p>
+            <a:pPr indent="0" marL="0">
+              <a:buNone/>
+            </a:pPr>
+            <a:r>
+              <a:rPr lang="en-US" sz="1400" dirty="0">
+                <a:solidFill>
+                  <a:srgbClr val="475569"/>
+                </a:solidFill>
+                <a:latin typeface="Microsoft YaHei" pitchFamily="34" charset="0"/>
+                <a:ea typeface="Microsoft YaHei" pitchFamily="34" charset="-122"/>
+                <a:cs typeface="Microsoft YaHei" pitchFamily="34" charset="-120"/>
+              </a:rPr>
+              <a:t>我们为演习制定了科学、立体的 SACS 融合评分算法，从四大维度对人机表现进行定量化考评：</a:t>
+            </a:r>
+            <a:endParaRPr lang="en-US" sz="1400" dirty="0"/>
+          </a:p>
+        </p:txBody>
+      </p:sp>
+      <p:sp>
+        <p:nvSpPr>
+          <p:cNvPr id="8" name="Shape 6"/>
+          <p:cNvSpPr/>
+          <p:nvPr/>
+        </p:nvSpPr>
+        <p:spPr>
+          <a:xfrm>
+            <a:off x="548640" y="1645920"/>
+            <a:ext cx="5303520" cy="2103120"/>
           </a:xfrm>
           <a:prstGeom prst="roundRect">
             <a:avLst/>
@@ -4874,14 +5003,14 @@
       </p:sp>
       <p:sp>
         <p:nvSpPr>
-          <p:cNvPr id="8" name="Text 6"/>
-          <p:cNvSpPr/>
-          <p:nvPr/>
-        </p:nvSpPr>
-        <p:spPr>
-          <a:xfrm>
-            <a:off x="822960" y="1645920"/>
-            <a:ext cx="4754880" cy="4297680"/>
+          <p:cNvPr id="9" name="Text 7"/>
+          <p:cNvSpPr/>
+          <p:nvPr/>
+        </p:nvSpPr>
+        <p:spPr>
+          <a:xfrm>
+            <a:off x="822960" y="1828800"/>
+            <a:ext cx="4754880" cy="1737360"/>
           </a:xfrm>
           <a:prstGeom prst="rect">
             <a:avLst/>
@@ -4900,7 +5029,7 @@
               <a:buNone/>
             </a:pPr>
             <a:r>
-              <a:rPr lang="en-US" sz="1800" b="1" dirty="0">
+              <a:rPr lang="en-US" sz="1600" b="1" dirty="0">
                 <a:solidFill>
                   <a:srgbClr val="0284C7"/>
                 </a:solidFill>
@@ -4908,7 +5037,7 @@
                 <a:ea typeface="Microsoft YaHei" pitchFamily="34" charset="-122"/>
                 <a:cs typeface="Microsoft YaHei" pitchFamily="34" charset="-120"/>
               </a:rPr>
-              <a:t>🔍 差异化快照剪枝算法 (Snapshot Pruning)
+              <a:t>⏱️ Speed (速度维度 - 权重 50%)
 </a:t>
             </a:r>
             <a:pPr indent="0" marL="0">
@@ -4918,23 +5047,6 @@
               <a:buNone/>
             </a:pPr>
             <a:r>
-              <a:rPr lang="en-US" sz="1250" b="1" dirty="0">
-                <a:solidFill>
-                  <a:srgbClr val="0F172A"/>
-                </a:solidFill>
-                <a:latin typeface="Microsoft YaHei" pitchFamily="34" charset="0"/>
-                <a:ea typeface="Microsoft YaHei" pitchFamily="34" charset="-122"/>
-                <a:cs typeface="Microsoft YaHei" pitchFamily="34" charset="-120"/>
-              </a:rPr>
-              <a:t>• 解决 SRE 日志巨量噪声：</a:t>
-            </a:r>
-            <a:pPr indent="0" marL="0">
-              <a:lnSpc>
-                <a:spcPts val="1800"/>
-              </a:lnSpc>
-              <a:buNone/>
-            </a:pPr>
-            <a:r>
               <a:rPr lang="en-US" sz="1250" dirty="0">
                 <a:solidFill>
                   <a:srgbClr val="475569"/>
@@ -4943,77 +5055,7 @@
                 <a:ea typeface="Microsoft YaHei" pitchFamily="34" charset="-122"/>
                 <a:cs typeface="Microsoft YaHei" pitchFamily="34" charset="-120"/>
               </a:rPr>
-              <a:t>微服务运行时数据泛滥，长上下文极易导致 LLM 决策迷失 (Lost in the Middle) 并推高 Token 费用。
-</a:t>
-            </a:r>
-            <a:pPr indent="0" marL="0">
-              <a:lnSpc>
-                <a:spcPts val="1800"/>
-              </a:lnSpc>
-              <a:buNone/>
-            </a:pPr>
-            <a:r>
-              <a:rPr lang="en-US" sz="1250" b="1" dirty="0">
-                <a:solidFill>
-                  <a:srgbClr val="0F172A"/>
-                </a:solidFill>
-                <a:latin typeface="Microsoft YaHei" pitchFamily="34" charset="0"/>
-                <a:ea typeface="Microsoft YaHei" pitchFamily="34" charset="-122"/>
-                <a:cs typeface="Microsoft YaHei" pitchFamily="34" charset="-120"/>
-              </a:rPr>
-              <a:t>• 黄金基线差异对比 (Baseline Diffing)：</a:t>
-            </a:r>
-            <a:pPr indent="0" marL="0">
-              <a:lnSpc>
-                <a:spcPts val="1800"/>
-              </a:lnSpc>
-              <a:buNone/>
-            </a:pPr>
-            <a:r>
-              <a:rPr lang="en-US" sz="1250" dirty="0">
-                <a:solidFill>
-                  <a:srgbClr val="475569"/>
-                </a:solidFill>
-                <a:latin typeface="Microsoft YaHei" pitchFamily="34" charset="0"/>
-                <a:ea typeface="Microsoft YaHei" pitchFamily="34" charset="-122"/>
-                <a:cs typeface="Microsoft YaHei" pitchFamily="34" charset="-120"/>
-              </a:rPr>
-              <a:t>系统自主实现快照剪枝。将当前时刻的 Pod、Deploy、Events 与系统健康时的基线作原子差异对比。自动剔除一切正常的服务细节和长串 UUID。
-</a:t>
-            </a:r>
-            <a:pPr indent="0" marL="0">
-              <a:lnSpc>
-                <a:spcPts val="1800"/>
-              </a:lnSpc>
-              <a:buNone/>
-            </a:pPr>
-            <a:r>
-              <a:rPr lang="en-US" sz="1250" b="1" dirty="0">
-                <a:solidFill>
-                  <a:srgbClr val="0F172A"/>
-                </a:solidFill>
-                <a:latin typeface="Microsoft YaHei" pitchFamily="34" charset="0"/>
-                <a:ea typeface="Microsoft YaHei" pitchFamily="34" charset="-122"/>
-                <a:cs typeface="Microsoft YaHei" pitchFamily="34" charset="-120"/>
-              </a:rPr>
-              <a:t>• 极限瘦身 75% 以上：</a:t>
-            </a:r>
-            <a:pPr indent="0" marL="0">
-              <a:lnSpc>
-                <a:spcPts val="1800"/>
-              </a:lnSpc>
-              <a:buNone/>
-            </a:pPr>
-            <a:r>
-              <a:rPr lang="en-US" sz="1250" dirty="0">
-                <a:solidFill>
-                  <a:srgbClr val="475569"/>
-                </a:solidFill>
-                <a:latin typeface="Microsoft YaHei" pitchFamily="34" charset="0"/>
-                <a:ea typeface="Microsoft YaHei" pitchFamily="34" charset="-122"/>
-                <a:cs typeface="Microsoft YaHei" pitchFamily="34" charset="-120"/>
-              </a:rPr>
-              <a:t>仅向 LLM 喂入高信噪比突发异常快照，将 AI 定位分析的确定性推升至工业级水准。</a:t>
+              <a:t>依据最终抢修完成的耗时呈线性数学衰减。自愈越快，速度得分越高；超时未完成为 0 分，高度量化时间压力实感。</a:t>
             </a:r>
             <a:endParaRPr lang="en-US" sz="1250" dirty="0"/>
           </a:p>
@@ -5021,14 +5063,14 @@
       </p:sp>
       <p:sp>
         <p:nvSpPr>
-          <p:cNvPr id="9" name="Shape 7"/>
-          <p:cNvSpPr/>
-          <p:nvPr/>
-        </p:nvSpPr>
-        <p:spPr>
-          <a:xfrm>
-            <a:off x="6309360" y="1463040"/>
-            <a:ext cx="5303520" cy="4663440"/>
+          <p:cNvPr id="10" name="Shape 8"/>
+          <p:cNvSpPr/>
+          <p:nvPr/>
+        </p:nvSpPr>
+        <p:spPr>
+          <a:xfrm>
+            <a:off x="6309360" y="1645920"/>
+            <a:ext cx="5303520" cy="2103120"/>
           </a:xfrm>
           <a:prstGeom prst="roundRect">
             <a:avLst/>
@@ -5046,14 +5088,14 @@
       </p:sp>
       <p:sp>
         <p:nvSpPr>
-          <p:cNvPr id="10" name="Text 8"/>
-          <p:cNvSpPr/>
-          <p:nvPr/>
-        </p:nvSpPr>
-        <p:spPr>
-          <a:xfrm>
-            <a:off x="6583680" y="1645920"/>
-            <a:ext cx="4754880" cy="4297680"/>
+          <p:cNvPr id="11" name="Text 9"/>
+          <p:cNvSpPr/>
+          <p:nvPr/>
+        </p:nvSpPr>
+        <p:spPr>
+          <a:xfrm>
+            <a:off x="6583680" y="1828800"/>
+            <a:ext cx="4754880" cy="1737360"/>
           </a:xfrm>
           <a:prstGeom prst="rect">
             <a:avLst/>
@@ -5067,12 +5109,97 @@
           <a:p>
             <a:pPr indent="0" marL="0">
               <a:lnSpc>
-                <a:spcPts val="1600"/>
-              </a:lnSpc>
-              <a:buNone/>
-            </a:pPr>
-            <a:r>
-              <a:rPr lang="en-US" sz="1800" b="1" dirty="0">
+                <a:spcPts val="1800"/>
+              </a:lnSpc>
+              <a:buNone/>
+            </a:pPr>
+            <a:r>
+              <a:rPr lang="en-US" sz="1600" b="1" dirty="0">
+                <a:solidFill>
+                  <a:srgbClr val="EA580C"/>
+                </a:solidFill>
+                <a:latin typeface="Microsoft YaHei" pitchFamily="34" charset="0"/>
+                <a:ea typeface="Microsoft YaHei" pitchFamily="34" charset="-122"/>
+                <a:cs typeface="Microsoft YaHei" pitchFamily="34" charset="-120"/>
+              </a:rPr>
+              <a:t>🎯 Accuracy (根因准确度 - 权重 20%)
+</a:t>
+            </a:r>
+            <a:pPr indent="0" marL="0">
+              <a:lnSpc>
+                <a:spcPts val="1800"/>
+              </a:lnSpc>
+              <a:buNone/>
+            </a:pPr>
+            <a:r>
+              <a:rPr lang="en-US" sz="1250" dirty="0">
+                <a:solidFill>
+                  <a:srgbClr val="475569"/>
+                </a:solidFill>
+                <a:latin typeface="Microsoft YaHei" pitchFamily="34" charset="0"/>
+                <a:ea typeface="Microsoft YaHei" pitchFamily="34" charset="-122"/>
+                <a:cs typeface="Microsoft YaHei" pitchFamily="34" charset="-120"/>
+              </a:rPr>
+              <a:t>评分引擎针对用户在终端敲击的指令历史与 AI 生成的诊断日志进行匹配，准确判定是否真正捕获了核心故障元，阻断盲目无序调试。</a:t>
+            </a:r>
+            <a:endParaRPr lang="en-US" sz="1250" dirty="0"/>
+          </a:p>
+        </p:txBody>
+      </p:sp>
+      <p:sp>
+        <p:nvSpPr>
+          <p:cNvPr id="12" name="Shape 10"/>
+          <p:cNvSpPr/>
+          <p:nvPr/>
+        </p:nvSpPr>
+        <p:spPr>
+          <a:xfrm>
+            <a:off x="548640" y="4023360"/>
+            <a:ext cx="5303520" cy="2103120"/>
+          </a:xfrm>
+          <a:prstGeom prst="roundRect">
+            <a:avLst/>
+          </a:prstGeom>
+          <a:solidFill>
+            <a:srgbClr val="FFFFFF"/>
+          </a:solidFill>
+          <a:ln w="12700">
+            <a:solidFill>
+              <a:srgbClr val="E2E8F0"/>
+            </a:solidFill>
+            <a:prstDash val="solid"/>
+          </a:ln>
+        </p:spPr>
+      </p:sp>
+      <p:sp>
+        <p:nvSpPr>
+          <p:cNvPr id="13" name="Text 11"/>
+          <p:cNvSpPr/>
+          <p:nvPr/>
+        </p:nvSpPr>
+        <p:spPr>
+          <a:xfrm>
+            <a:off x="822960" y="4206240"/>
+            <a:ext cx="4754880" cy="1737360"/>
+          </a:xfrm>
+          <a:prstGeom prst="rect">
+            <a:avLst/>
+          </a:prstGeom>
+          <a:noFill/>
+          <a:ln/>
+        </p:spPr>
+        <p:txBody>
+          <a:bodyPr wrap="square" rtlCol="0" anchor="ctr"/>
+          <a:lstStyle/>
+          <a:p>
+            <a:pPr indent="0" marL="0">
+              <a:lnSpc>
+                <a:spcPts val="1800"/>
+              </a:lnSpc>
+              <a:buNone/>
+            </a:pPr>
+            <a:r>
+              <a:rPr lang="en-US" sz="1600" b="1" dirty="0">
                 <a:solidFill>
                   <a:srgbClr val="10B981"/>
                 </a:solidFill>
@@ -5080,17 +5207,84 @@
                 <a:ea typeface="Microsoft YaHei" pitchFamily="34" charset="-122"/>
                 <a:cs typeface="Microsoft YaHei" pitchFamily="34" charset="-120"/>
               </a:rPr>
-              <a:t>🤖 OODA 循环闭环自愈 Agent
+              <a:t>💸 Cost (开销预算度 - 权重 15%)
 </a:t>
             </a:r>
             <a:pPr indent="0" marL="0">
               <a:lnSpc>
-                <a:spcPts val="1600"/>
-              </a:lnSpc>
-              <a:buNone/>
-            </a:pPr>
-            <a:r>
-              <a:rPr lang="en-US" sz="1200" b="1" dirty="0">
+                <a:spcPts val="1800"/>
+              </a:lnSpc>
+              <a:buNone/>
+            </a:pPr>
+            <a:r>
+              <a:rPr lang="en-US" sz="1250" dirty="0">
+                <a:solidFill>
+                  <a:srgbClr val="475569"/>
+                </a:solidFill>
+                <a:latin typeface="Microsoft YaHei" pitchFamily="34" charset="0"/>
+                <a:ea typeface="Microsoft YaHei" pitchFamily="34" charset="-122"/>
+                <a:cs typeface="Microsoft YaHei" pitchFamily="34" charset="-120"/>
+              </a:rPr>
+              <a:t>引入虚拟资金预算机制。人类每敲入更改状态指令，或者 AI 每轮大模型交互调用均会扣除预算。惩罚盲目排障，倡导一击即中。</a:t>
+            </a:r>
+            <a:endParaRPr lang="en-US" sz="1250" dirty="0"/>
+          </a:p>
+        </p:txBody>
+      </p:sp>
+      <p:sp>
+        <p:nvSpPr>
+          <p:cNvPr id="14" name="Shape 12"/>
+          <p:cNvSpPr/>
+          <p:nvPr/>
+        </p:nvSpPr>
+        <p:spPr>
+          <a:xfrm>
+            <a:off x="6309360" y="4023360"/>
+            <a:ext cx="5303520" cy="2103120"/>
+          </a:xfrm>
+          <a:prstGeom prst="roundRect">
+            <a:avLst/>
+          </a:prstGeom>
+          <a:solidFill>
+            <a:srgbClr val="FFFFFF"/>
+          </a:solidFill>
+          <a:ln w="12700">
+            <a:solidFill>
+              <a:srgbClr val="E2E8F0"/>
+            </a:solidFill>
+            <a:prstDash val="solid"/>
+          </a:ln>
+        </p:spPr>
+      </p:sp>
+      <p:sp>
+        <p:nvSpPr>
+          <p:cNvPr id="15" name="Text 13"/>
+          <p:cNvSpPr/>
+          <p:nvPr/>
+        </p:nvSpPr>
+        <p:spPr>
+          <a:xfrm>
+            <a:off x="6583680" y="4206240"/>
+            <a:ext cx="4754880" cy="1737360"/>
+          </a:xfrm>
+          <a:prstGeom prst="rect">
+            <a:avLst/>
+          </a:prstGeom>
+          <a:noFill/>
+          <a:ln/>
+        </p:spPr>
+        <p:txBody>
+          <a:bodyPr wrap="square" rtlCol="0" anchor="ctr"/>
+          <a:lstStyle/>
+          <a:p>
+            <a:pPr indent="0" marL="0">
+              <a:lnSpc>
+                <a:spcPts val="1800"/>
+              </a:lnSpc>
+              <a:buNone/>
+            </a:pPr>
+            <a:r>
+              <a:rPr lang="en-US" sz="1600" b="1" dirty="0">
                 <a:solidFill>
                   <a:srgbClr val="0F172A"/>
                 </a:solidFill>
@@ -5098,16 +5292,17 @@
                 <a:ea typeface="Microsoft YaHei" pitchFamily="34" charset="-122"/>
                 <a:cs typeface="Microsoft YaHei" pitchFamily="34" charset="-120"/>
               </a:rPr>
-              <a:t>• OODA 理论完美闭环：</a:t>
-            </a:r>
-            <a:pPr indent="0" marL="0">
-              <a:lnSpc>
-                <a:spcPts val="1600"/>
-              </a:lnSpc>
-              <a:buNone/>
-            </a:pPr>
-            <a:r>
-              <a:rPr lang="en-US" sz="1200" dirty="0">
+              <a:t>📋 Standard (操作规范度 - 权重 15%)
+</a:t>
+            </a:r>
+            <a:pPr indent="0" marL="0">
+              <a:lnSpc>
+                <a:spcPts val="1800"/>
+              </a:lnSpc>
+              <a:buNone/>
+            </a:pPr>
+            <a:r>
+              <a:rPr lang="en-US" sz="1250" dirty="0">
                 <a:solidFill>
                   <a:srgbClr val="475569"/>
                 </a:solidFill>
@@ -5115,98 +5310,9 @@
                 <a:ea typeface="Microsoft YaHei" pitchFamily="34" charset="-122"/>
                 <a:cs typeface="Microsoft YaHei" pitchFamily="34" charset="-120"/>
               </a:rPr>
-              <a:t>  - Observe (观察)：每 5 秒拉取降噪后的高精度快照。
-</a:t>
-            </a:r>
-            <a:pPr indent="0" marL="0">
-              <a:lnSpc>
-                <a:spcPts val="1600"/>
-              </a:lnSpc>
-              <a:buNone/>
-            </a:pPr>
-            <a:r>
-              <a:rPr lang="en-US" sz="1200" dirty="0">
-                <a:solidFill>
-                  <a:srgbClr val="475569"/>
-                </a:solidFill>
-                <a:latin typeface="Microsoft YaHei" pitchFamily="34" charset="0"/>
-                <a:ea typeface="Microsoft YaHei" pitchFamily="34" charset="-122"/>
-                <a:cs typeface="Microsoft YaHei" pitchFamily="34" charset="-120"/>
-              </a:rPr>
-              <a:t>  - Orient (调整)：拓扑分析，理清微服务故障扩散链。
-</a:t>
-            </a:r>
-            <a:pPr indent="0" marL="0">
-              <a:lnSpc>
-                <a:spcPts val="1600"/>
-              </a:lnSpc>
-              <a:buNone/>
-            </a:pPr>
-            <a:r>
-              <a:rPr lang="en-US" sz="1200" dirty="0">
-                <a:solidFill>
-                  <a:srgbClr val="475569"/>
-                </a:solidFill>
-                <a:latin typeface="Microsoft YaHei" pitchFamily="34" charset="0"/>
-                <a:ea typeface="Microsoft YaHei" pitchFamily="34" charset="-122"/>
-                <a:cs typeface="Microsoft YaHei" pitchFamily="34" charset="-120"/>
-              </a:rPr>
-              <a:t>  - Decide (决策)：LLM 根据上下文智能决策修复脚本。
-</a:t>
-            </a:r>
-            <a:pPr indent="0" marL="0">
-              <a:lnSpc>
-                <a:spcPts val="1600"/>
-              </a:lnSpc>
-              <a:buNone/>
-            </a:pPr>
-            <a:r>
-              <a:rPr lang="en-US" sz="1200" dirty="0">
-                <a:solidFill>
-                  <a:srgbClr val="475569"/>
-                </a:solidFill>
-                <a:latin typeface="Microsoft YaHei" pitchFamily="34" charset="0"/>
-                <a:ea typeface="Microsoft YaHei" pitchFamily="34" charset="-122"/>
-                <a:cs typeface="Microsoft YaHei" pitchFamily="34" charset="-120"/>
-              </a:rPr>
-              <a:t>  - Action (执行)：自动执行 kubectl 命令并在调谐环路中迭代检验修复结果，实现了闭环全自愈。
-</a:t>
-            </a:r>
-            <a:pPr indent="0" marL="0">
-              <a:lnSpc>
-                <a:spcPts val="1600"/>
-              </a:lnSpc>
-              <a:buNone/>
-            </a:pPr>
-            <a:r>
-              <a:rPr lang="en-US" sz="1200" b="1" dirty="0">
-                <a:solidFill>
-                  <a:srgbClr val="0F172A"/>
-                </a:solidFill>
-                <a:latin typeface="Microsoft YaHei" pitchFamily="34" charset="0"/>
-                <a:ea typeface="Microsoft YaHei" pitchFamily="34" charset="-122"/>
-                <a:cs typeface="Microsoft YaHei" pitchFamily="34" charset="-120"/>
-              </a:rPr>
-              <a:t>• 推理链白盒可视化：</a:t>
-            </a:r>
-            <a:pPr indent="0" marL="0">
-              <a:lnSpc>
-                <a:spcPts val="1600"/>
-              </a:lnSpc>
-              <a:buNone/>
-            </a:pPr>
-            <a:r>
-              <a:rPr lang="en-US" sz="1200" dirty="0">
-                <a:solidFill>
-                  <a:srgbClr val="475569"/>
-                </a:solidFill>
-                <a:latin typeface="Microsoft YaHei" pitchFamily="34" charset="0"/>
-                <a:ea typeface="Microsoft YaHei" pitchFamily="34" charset="-122"/>
-                <a:cs typeface="Microsoft YaHei" pitchFamily="34" charset="-120"/>
-              </a:rPr>
-              <a:t>AI 每次的怀疑对象与思考逻辑（CoT）实时推送到大屏，将盲盒打分提升为高价值人机协同教学。</a:t>
-            </a:r>
-            <a:endParaRPr lang="en-US" sz="1200" dirty="0"/>
+              <a:t>全面监控输入的语法错误、冗余指令和无意义获取。以极其严谨的标准规范日常操作作风，培养高水平 SRE 极客底色。</a:t>
+            </a:r>
+            <a:endParaRPr lang="en-US" sz="1250" dirty="0"/>
           </a:p>
         </p:txBody>
       </p:sp>
@@ -5295,7 +5401,7 @@
                 <a:ea typeface="Microsoft YaHei" pitchFamily="34" charset="-122"/>
                 <a:cs typeface="Microsoft YaHei" pitchFamily="34" charset="-120"/>
               </a:rPr>
-              <a:t>6. 严谨的评分标准与多维度量化体系</a:t>
+              <a:t>6. 真实环境混沌注入与工程覆盖</a:t>
             </a:r>
             <a:endParaRPr lang="en-US" sz="2600" dirty="0"/>
           </a:p>
@@ -5334,7 +5440,7 @@
                 <a:ea typeface="Microsoft YaHei" pitchFamily="34" charset="-122"/>
                 <a:cs typeface="Microsoft YaHei" pitchFamily="34" charset="-120"/>
               </a:rPr>
-              <a:t>SACS MULTI-DIMENSIONAL SCORING SYSTEM</a:t>
+              <a:t>EXPERIMENTAL OUTCOMES &amp; VERIFICATION</a:t>
             </a:r>
             <a:endParaRPr lang="en-US" sz="1200" dirty="0"/>
           </a:p>
@@ -5401,53 +5507,14 @@
       </p:sp>
       <p:sp>
         <p:nvSpPr>
-          <p:cNvPr id="7" name="Text 5"/>
-          <p:cNvSpPr/>
-          <p:nvPr/>
-        </p:nvSpPr>
-        <p:spPr>
-          <a:xfrm>
-            <a:off x="548640" y="1280160"/>
-            <a:ext cx="10972800" cy="274320"/>
-          </a:xfrm>
-          <a:prstGeom prst="rect">
-            <a:avLst/>
-          </a:prstGeom>
-          <a:noFill/>
-          <a:ln/>
-        </p:spPr>
-        <p:txBody>
-          <a:bodyPr wrap="square" rtlCol="0" anchor="ctr"/>
-          <a:lstStyle/>
-          <a:p>
-            <a:pPr indent="0" marL="0">
-              <a:buNone/>
-            </a:pPr>
-            <a:r>
-              <a:rPr lang="en-US" sz="1400" dirty="0">
-                <a:solidFill>
-                  <a:srgbClr val="475569"/>
-                </a:solidFill>
-                <a:latin typeface="Microsoft YaHei" pitchFamily="34" charset="0"/>
-                <a:ea typeface="Microsoft YaHei" pitchFamily="34" charset="-122"/>
-                <a:cs typeface="Microsoft YaHei" pitchFamily="34" charset="-120"/>
-              </a:rPr>
-              <a:t>我们为演习制定了科学、立体的 SACS 融合评分算法，从四大维度对人机表现进行定量化考评：</a:t>
-            </a:r>
-            <a:endParaRPr lang="en-US" sz="1400" dirty="0"/>
-          </a:p>
-        </p:txBody>
-      </p:sp>
-      <p:sp>
-        <p:nvSpPr>
-          <p:cNvPr id="8" name="Shape 6"/>
-          <p:cNvSpPr/>
-          <p:nvPr/>
-        </p:nvSpPr>
-        <p:spPr>
-          <a:xfrm>
-            <a:off x="548640" y="1645920"/>
-            <a:ext cx="5303520" cy="2103120"/>
+          <p:cNvPr id="7" name="Shape 5"/>
+          <p:cNvSpPr/>
+          <p:nvPr/>
+        </p:nvSpPr>
+        <p:spPr>
+          <a:xfrm>
+            <a:off x="548640" y="1463040"/>
+            <a:ext cx="5303520" cy="4663440"/>
           </a:xfrm>
           <a:prstGeom prst="roundRect">
             <a:avLst/>
@@ -5465,14 +5532,14 @@
       </p:sp>
       <p:sp>
         <p:nvSpPr>
-          <p:cNvPr id="9" name="Text 7"/>
-          <p:cNvSpPr/>
-          <p:nvPr/>
-        </p:nvSpPr>
-        <p:spPr>
-          <a:xfrm>
-            <a:off x="822960" y="1828800"/>
-            <a:ext cx="4754880" cy="1737360"/>
+          <p:cNvPr id="8" name="Text 6"/>
+          <p:cNvSpPr/>
+          <p:nvPr/>
+        </p:nvSpPr>
+        <p:spPr>
+          <a:xfrm>
+            <a:off x="822960" y="1645920"/>
+            <a:ext cx="4754880" cy="4297680"/>
           </a:xfrm>
           <a:prstGeom prst="rect">
             <a:avLst/>
@@ -5486,12 +5553,12 @@
           <a:p>
             <a:pPr indent="0" marL="0">
               <a:lnSpc>
-                <a:spcPts val="1800"/>
-              </a:lnSpc>
-              <a:buNone/>
-            </a:pPr>
-            <a:r>
-              <a:rPr lang="en-US" sz="1600" b="1" dirty="0">
+                <a:spcPts val="1600"/>
+              </a:lnSpc>
+              <a:buNone/>
+            </a:pPr>
+            <a:r>
+              <a:rPr lang="en-US" sz="1800" b="1" dirty="0">
                 <a:solidFill>
                   <a:srgbClr val="0284C7"/>
                 </a:solidFill>
@@ -5499,12 +5566,30 @@
                 <a:ea typeface="Microsoft YaHei" pitchFamily="34" charset="-122"/>
                 <a:cs typeface="Microsoft YaHei" pitchFamily="34" charset="-120"/>
               </a:rPr>
-              <a:t>⏱️ Speed (速度维度 - 权重 50%)
+              <a:t>🚀 物理靶场真实注入实测
 </a:t>
             </a:r>
             <a:pPr indent="0" marL="0">
               <a:lnSpc>
-                <a:spcPts val="1800"/>
+                <a:spcPts val="1600"/>
+              </a:lnSpc>
+              <a:buNone/>
+            </a:pPr>
+            <a:r>
+              <a:rPr lang="en-US" sz="1250" b="1" dirty="0">
+                <a:solidFill>
+                  <a:srgbClr val="0F172A"/>
+                </a:solidFill>
+                <a:latin typeface="Microsoft YaHei" pitchFamily="34" charset="0"/>
+                <a:ea typeface="Microsoft YaHei" pitchFamily="34" charset="-122"/>
+                <a:cs typeface="Microsoft YaHei" pitchFamily="34" charset="-120"/>
+              </a:rPr>
+              <a:t>• 简单模式 (Easy Mode)：
+</a:t>
+            </a:r>
+            <a:pPr indent="0" marL="0">
+              <a:lnSpc>
+                <a:spcPts val="1600"/>
               </a:lnSpc>
               <a:buNone/>
             </a:pPr>
@@ -5517,7 +5602,79 @@
                 <a:ea typeface="Microsoft YaHei" pitchFamily="34" charset="-122"/>
                 <a:cs typeface="Microsoft YaHei" pitchFamily="34" charset="-120"/>
               </a:rPr>
-              <a:t>依据最终抢修完成的耗时呈线性数学衰减。自愈越快，速度得分越高；超时未完成为 0 分，高度量化应急时效实感。</a:t>
+              <a:t>  - 注入 order-service 磁盘满故障，产生 64MB 临时大文件。
+</a:t>
+            </a:r>
+            <a:pPr indent="0" marL="0">
+              <a:lnSpc>
+                <a:spcPts val="1600"/>
+              </a:lnSpc>
+              <a:buNone/>
+            </a:pPr>
+            <a:r>
+              <a:rPr lang="en-US" sz="1250" dirty="0">
+                <a:solidFill>
+                  <a:srgbClr val="475569"/>
+                </a:solidFill>
+                <a:latin typeface="Microsoft YaHei" pitchFamily="34" charset="0"/>
+                <a:ea typeface="Microsoft YaHei" pitchFamily="34" charset="-122"/>
+                <a:cs typeface="Microsoft YaHei" pitchFamily="34" charset="-120"/>
+              </a:rPr>
+              <a:t>  - 人类利用终端精准捕获大文件路径并极速删除，集群立即自愈。
+</a:t>
+            </a:r>
+            <a:pPr indent="0" marL="0">
+              <a:lnSpc>
+                <a:spcPts val="1600"/>
+              </a:lnSpc>
+              <a:buNone/>
+            </a:pPr>
+            <a:r>
+              <a:rPr lang="en-US" sz="1250" b="1" dirty="0">
+                <a:solidFill>
+                  <a:srgbClr val="0F172A"/>
+                </a:solidFill>
+                <a:latin typeface="Microsoft YaHei" pitchFamily="34" charset="0"/>
+                <a:ea typeface="Microsoft YaHei" pitchFamily="34" charset="-122"/>
+                <a:cs typeface="Microsoft YaHei" pitchFamily="34" charset="-120"/>
+              </a:rPr>
+              <a:t>• 困难模式 (Hard Mode)：
+</a:t>
+            </a:r>
+            <a:pPr indent="0" marL="0">
+              <a:lnSpc>
+                <a:spcPts val="1600"/>
+              </a:lnSpc>
+              <a:buNone/>
+            </a:pPr>
+            <a:r>
+              <a:rPr lang="en-US" sz="1250" dirty="0">
+                <a:solidFill>
+                  <a:srgbClr val="475569"/>
+                </a:solidFill>
+                <a:latin typeface="Microsoft YaHei" pitchFamily="34" charset="0"/>
+                <a:ea typeface="Microsoft YaHei" pitchFamily="34" charset="-122"/>
+                <a:cs typeface="Microsoft YaHei" pitchFamily="34" charset="-120"/>
+              </a:rPr>
+              <a:t>  - 并发注入 product-service 缩零与 order-service PID 1 终结崩溃。
+</a:t>
+            </a:r>
+            <a:pPr indent="0" marL="0">
+              <a:lnSpc>
+                <a:spcPts val="1600"/>
+              </a:lnSpc>
+              <a:buNone/>
+            </a:pPr>
+            <a:r>
+              <a:rPr lang="en-US" sz="1250" dirty="0">
+                <a:solidFill>
+                  <a:srgbClr val="475569"/>
+                </a:solidFill>
+                <a:latin typeface="Microsoft YaHei" pitchFamily="34" charset="0"/>
+                <a:ea typeface="Microsoft YaHei" pitchFamily="34" charset="-122"/>
+                <a:cs typeface="Microsoft YaHei" pitchFamily="34" charset="-120"/>
+              </a:rPr>
+              <a:t>  - AI 利用 OODA 基线差异分析，20 秒内推荐并下发 `kubectl scale` 重构 product-service，展现了卓越的自动化自愈应急力。</a:t>
             </a:r>
             <a:endParaRPr lang="en-US" sz="1250" dirty="0"/>
           </a:p>
@@ -5525,14 +5682,14 @@
       </p:sp>
       <p:sp>
         <p:nvSpPr>
-          <p:cNvPr id="10" name="Shape 8"/>
-          <p:cNvSpPr/>
-          <p:nvPr/>
-        </p:nvSpPr>
-        <p:spPr>
-          <a:xfrm>
-            <a:off x="6309360" y="1645920"/>
-            <a:ext cx="5303520" cy="2103120"/>
+          <p:cNvPr id="9" name="Shape 7"/>
+          <p:cNvSpPr/>
+          <p:nvPr/>
+        </p:nvSpPr>
+        <p:spPr>
+          <a:xfrm>
+            <a:off x="6309360" y="1463040"/>
+            <a:ext cx="5303520" cy="4663440"/>
           </a:xfrm>
           <a:prstGeom prst="roundRect">
             <a:avLst/>
@@ -5550,14 +5707,14 @@
       </p:sp>
       <p:sp>
         <p:nvSpPr>
-          <p:cNvPr id="11" name="Text 9"/>
-          <p:cNvSpPr/>
-          <p:nvPr/>
-        </p:nvSpPr>
-        <p:spPr>
-          <a:xfrm>
-            <a:off x="6583680" y="1828800"/>
-            <a:ext cx="4754880" cy="1737360"/>
+          <p:cNvPr id="10" name="Text 8"/>
+          <p:cNvSpPr/>
+          <p:nvPr/>
+        </p:nvSpPr>
+        <p:spPr>
+          <a:xfrm>
+            <a:off x="6583680" y="1645920"/>
+            <a:ext cx="4754880" cy="4297680"/>
           </a:xfrm>
           <a:prstGeom prst="rect">
             <a:avLst/>
@@ -5571,30 +5728,155 @@
           <a:p>
             <a:pPr indent="0" marL="0">
               <a:lnSpc>
-                <a:spcPts val="1800"/>
-              </a:lnSpc>
-              <a:buNone/>
-            </a:pPr>
-            <a:r>
-              <a:rPr lang="en-US" sz="1600" b="1" dirty="0">
-                <a:solidFill>
-                  <a:srgbClr val="EA580C"/>
-                </a:solidFill>
-                <a:latin typeface="Microsoft YaHei" pitchFamily="34" charset="0"/>
-                <a:ea typeface="Microsoft YaHei" pitchFamily="34" charset="-122"/>
-                <a:cs typeface="Microsoft YaHei" pitchFamily="34" charset="-120"/>
-              </a:rPr>
-              <a:t>🎯 Accuracy (根因准确度 - 权重 20%)
+                <a:spcPts val="1400"/>
+              </a:lnSpc>
+              <a:buNone/>
+            </a:pPr>
+            <a:r>
+              <a:rPr lang="en-US" sz="1800" b="1" dirty="0">
+                <a:solidFill>
+                  <a:srgbClr val="10B981"/>
+                </a:solidFill>
+                <a:latin typeface="Microsoft YaHei" pitchFamily="34" charset="0"/>
+                <a:ea typeface="Microsoft YaHei" pitchFamily="34" charset="-122"/>
+                <a:cs typeface="Microsoft YaHei" pitchFamily="34" charset="-120"/>
+              </a:rPr>
+              <a:t>🧪 健全的自动化测试组件
 </a:t>
             </a:r>
             <a:pPr indent="0" marL="0">
               <a:lnSpc>
-                <a:spcPts val="1800"/>
-              </a:lnSpc>
-              <a:buNone/>
-            </a:pPr>
-            <a:r>
-              <a:rPr lang="en-US" sz="1250" dirty="0">
+                <a:spcPts val="1400"/>
+              </a:lnSpc>
+              <a:buNone/>
+            </a:pPr>
+            <a:r>
+              <a:rPr lang="en-US" sz="1200" b="1" dirty="0">
+                <a:solidFill>
+                  <a:srgbClr val="0F172A"/>
+                </a:solidFill>
+                <a:latin typeface="Microsoft YaHei" pitchFamily="34" charset="0"/>
+                <a:ea typeface="Microsoft YaHei" pitchFamily="34" charset="-122"/>
+                <a:cs typeface="Microsoft YaHei" pitchFamily="34" charset="-120"/>
+              </a:rPr>
+              <a:t>项目引入了基于 Jest 框架的工业级自动化测试覆盖：
+</a:t>
+            </a:r>
+            <a:pPr indent="0" marL="0">
+              <a:lnSpc>
+                <a:spcPts val="1400"/>
+              </a:lnSpc>
+              <a:buNone/>
+            </a:pPr>
+            <a:r>
+              <a:rPr lang="en-US" sz="1200" dirty="0">
+                <a:solidFill>
+                  <a:srgbClr val="10B981"/>
+                </a:solidFill>
+                <a:latin typeface="Microsoft YaHei" pitchFamily="34" charset="0"/>
+                <a:ea typeface="Microsoft YaHei" pitchFamily="34" charset="-122"/>
+                <a:cs typeface="Microsoft YaHei" pitchFamily="34" charset="-120"/>
+              </a:rPr>
+              <a:t>✔ PASS  __tests__/scorer.test.js
+</a:t>
+            </a:r>
+            <a:pPr indent="0" marL="0">
+              <a:lnSpc>
+                <a:spcPts val="1400"/>
+              </a:lnSpc>
+              <a:buNone/>
+            </a:pPr>
+            <a:r>
+              <a:rPr lang="en-US" sz="1200" dirty="0">
+                <a:solidFill>
+                  <a:srgbClr val="10B981"/>
+                </a:solidFill>
+                <a:latin typeface="Microsoft YaHei" pitchFamily="34" charset="0"/>
+                <a:ea typeface="Microsoft YaHei" pitchFamily="34" charset="-122"/>
+                <a:cs typeface="Microsoft YaHei" pitchFamily="34" charset="-120"/>
+              </a:rPr>
+              <a:t>✔ PASS  __tests__/chaos-injector.test.js
+</a:t>
+            </a:r>
+            <a:pPr indent="0" marL="0">
+              <a:lnSpc>
+                <a:spcPts val="1400"/>
+              </a:lnSpc>
+              <a:buNone/>
+            </a:pPr>
+            <a:r>
+              <a:rPr lang="en-US" sz="1200" dirty="0">
+                <a:solidFill>
+                  <a:srgbClr val="10B981"/>
+                </a:solidFill>
+                <a:latin typeface="Microsoft YaHei" pitchFamily="34" charset="0"/>
+                <a:ea typeface="Microsoft YaHei" pitchFamily="34" charset="-122"/>
+                <a:cs typeface="Microsoft YaHei" pitchFamily="34" charset="-120"/>
+              </a:rPr>
+              <a:t>✔ PASS  __tests__/terminal-proxy.test.js
+</a:t>
+            </a:r>
+            <a:pPr indent="0" marL="0">
+              <a:lnSpc>
+                <a:spcPts val="1400"/>
+              </a:lnSpc>
+              <a:buNone/>
+            </a:pPr>
+            <a:r>
+              <a:rPr lang="en-US" sz="1200" dirty="0">
+                <a:solidFill>
+                  <a:srgbClr val="10B981"/>
+                </a:solidFill>
+                <a:latin typeface="Microsoft YaHei" pitchFamily="34" charset="0"/>
+                <a:ea typeface="Microsoft YaHei" pitchFamily="34" charset="-122"/>
+                <a:cs typeface="Microsoft YaHei" pitchFamily="34" charset="-120"/>
+              </a:rPr>
+              <a:t>✔ PASS  __tests__/ai-engine.test.js
+</a:t>
+            </a:r>
+            <a:pPr indent="0" marL="0">
+              <a:lnSpc>
+                <a:spcPts val="1400"/>
+              </a:lnSpc>
+              <a:buNone/>
+            </a:pPr>
+            <a:r>
+              <a:rPr lang="en-US" sz="1200" dirty="0">
+                <a:solidFill>
+                  <a:srgbClr val="10B981"/>
+                </a:solidFill>
+                <a:latin typeface="Microsoft YaHei" pitchFamily="34" charset="0"/>
+                <a:ea typeface="Microsoft YaHei" pitchFamily="34" charset="-122"/>
+                <a:cs typeface="Microsoft YaHei" pitchFamily="34" charset="-120"/>
+              </a:rPr>
+              <a:t>✔ PASS  __tests__/integration.test.js
+</a:t>
+            </a:r>
+            <a:pPr indent="0" marL="0">
+              <a:lnSpc>
+                <a:spcPts val="1400"/>
+              </a:lnSpc>
+              <a:buNone/>
+            </a:pPr>
+            <a:r>
+              <a:rPr lang="en-US" sz="1200" b="1" dirty="0">
+                <a:solidFill>
+                  <a:srgbClr val="0F172A"/>
+                </a:solidFill>
+                <a:latin typeface="Microsoft YaHei" pitchFamily="34" charset="0"/>
+                <a:ea typeface="Microsoft YaHei" pitchFamily="34" charset="-122"/>
+                <a:cs typeface="Microsoft YaHei" pitchFamily="34" charset="-120"/>
+              </a:rPr>
+              <a:t>• 累计通过：</a:t>
+            </a:r>
+            <a:pPr indent="0" marL="0">
+              <a:lnSpc>
+                <a:spcPts val="1400"/>
+              </a:lnSpc>
+              <a:buNone/>
+            </a:pPr>
+            <a:r>
+              <a:rPr lang="en-US" sz="1200" dirty="0">
                 <a:solidFill>
                   <a:srgbClr val="475569"/>
                 </a:solidFill>
@@ -5602,84 +5884,34 @@
                 <a:ea typeface="Microsoft YaHei" pitchFamily="34" charset="-122"/>
                 <a:cs typeface="Microsoft YaHei" pitchFamily="34" charset="-120"/>
               </a:rPr>
-              <a:t>评分引擎针对用户在终端敲击的指令历史与 AI 生成的诊断日志进行匹配，准确判定是否真正捕获了核心故障元，阻断盲目无序调试。</a:t>
-            </a:r>
-            <a:endParaRPr lang="en-US" sz="1250" dirty="0"/>
-          </a:p>
-        </p:txBody>
-      </p:sp>
-      <p:sp>
-        <p:nvSpPr>
-          <p:cNvPr id="12" name="Shape 10"/>
-          <p:cNvSpPr/>
-          <p:nvPr/>
-        </p:nvSpPr>
-        <p:spPr>
-          <a:xfrm>
-            <a:off x="548640" y="4023360"/>
-            <a:ext cx="5303520" cy="2103120"/>
-          </a:xfrm>
-          <a:prstGeom prst="roundRect">
-            <a:avLst/>
-          </a:prstGeom>
-          <a:solidFill>
-            <a:srgbClr val="FFFFFF"/>
-          </a:solidFill>
-          <a:ln w="12700">
-            <a:solidFill>
-              <a:srgbClr val="E2E8F0"/>
-            </a:solidFill>
-            <a:prstDash val="solid"/>
-          </a:ln>
-        </p:spPr>
-      </p:sp>
-      <p:sp>
-        <p:nvSpPr>
-          <p:cNvPr id="13" name="Text 11"/>
-          <p:cNvSpPr/>
-          <p:nvPr/>
-        </p:nvSpPr>
-        <p:spPr>
-          <a:xfrm>
-            <a:off x="822960" y="4206240"/>
-            <a:ext cx="4754880" cy="1737360"/>
-          </a:xfrm>
-          <a:prstGeom prst="rect">
-            <a:avLst/>
-          </a:prstGeom>
-          <a:noFill/>
-          <a:ln/>
-        </p:spPr>
-        <p:txBody>
-          <a:bodyPr wrap="square" rtlCol="0" anchor="ctr"/>
-          <a:lstStyle/>
-          <a:p>
-            <a:pPr indent="0" marL="0">
-              <a:lnSpc>
-                <a:spcPts val="1800"/>
-              </a:lnSpc>
-              <a:buNone/>
-            </a:pPr>
-            <a:r>
-              <a:rPr lang="en-US" sz="1600" b="1" dirty="0">
-                <a:solidFill>
-                  <a:srgbClr val="10B981"/>
-                </a:solidFill>
-                <a:latin typeface="Microsoft YaHei" pitchFamily="34" charset="0"/>
-                <a:ea typeface="Microsoft YaHei" pitchFamily="34" charset="-122"/>
-                <a:cs typeface="Microsoft YaHei" pitchFamily="34" charset="-120"/>
-              </a:rPr>
-              <a:t>💸 Cost (开销预算度 - 权重 15%)
+              <a:t>108 个底层核心单元/集成测试用例。
 </a:t>
             </a:r>
             <a:pPr indent="0" marL="0">
               <a:lnSpc>
-                <a:spcPts val="1800"/>
-              </a:lnSpc>
-              <a:buNone/>
-            </a:pPr>
-            <a:r>
-              <a:rPr lang="en-US" sz="1250" dirty="0">
+                <a:spcPts val="1400"/>
+              </a:lnSpc>
+              <a:buNone/>
+            </a:pPr>
+            <a:r>
+              <a:rPr lang="en-US" sz="1200" b="1" dirty="0">
+                <a:solidFill>
+                  <a:srgbClr val="0F172A"/>
+                </a:solidFill>
+                <a:latin typeface="Microsoft YaHei" pitchFamily="34" charset="0"/>
+                <a:ea typeface="Microsoft YaHei" pitchFamily="34" charset="-122"/>
+                <a:cs typeface="Microsoft YaHei" pitchFamily="34" charset="-120"/>
+              </a:rPr>
+              <a:t>• 高抗覆盖：</a:t>
+            </a:r>
+            <a:pPr indent="0" marL="0">
+              <a:lnSpc>
+                <a:spcPts val="1400"/>
+              </a:lnSpc>
+              <a:buNone/>
+            </a:pPr>
+            <a:r>
+              <a:rPr lang="en-US" sz="1200" dirty="0">
                 <a:solidFill>
                   <a:srgbClr val="475569"/>
                 </a:solidFill>
@@ -5687,94 +5919,9 @@
                 <a:ea typeface="Microsoft YaHei" pitchFamily="34" charset="-122"/>
                 <a:cs typeface="Microsoft YaHei" pitchFamily="34" charset="-120"/>
               </a:rPr>
-              <a:t>引入虚拟资金预算机制。人类每敲入更改状态指令，或者 AI 每轮交互调用均会扣除预算。惩罚盲目排障，倡导一击即中。</a:t>
-            </a:r>
-            <a:endParaRPr lang="en-US" sz="1250" dirty="0"/>
-          </a:p>
-        </p:txBody>
-      </p:sp>
-      <p:sp>
-        <p:nvSpPr>
-          <p:cNvPr id="14" name="Shape 12"/>
-          <p:cNvSpPr/>
-          <p:nvPr/>
-        </p:nvSpPr>
-        <p:spPr>
-          <a:xfrm>
-            <a:off x="6309360" y="4023360"/>
-            <a:ext cx="5303520" cy="2103120"/>
-          </a:xfrm>
-          <a:prstGeom prst="roundRect">
-            <a:avLst/>
-          </a:prstGeom>
-          <a:solidFill>
-            <a:srgbClr val="FFFFFF"/>
-          </a:solidFill>
-          <a:ln w="12700">
-            <a:solidFill>
-              <a:srgbClr val="E2E8F0"/>
-            </a:solidFill>
-            <a:prstDash val="solid"/>
-          </a:ln>
-        </p:spPr>
-      </p:sp>
-      <p:sp>
-        <p:nvSpPr>
-          <p:cNvPr id="15" name="Text 13"/>
-          <p:cNvSpPr/>
-          <p:nvPr/>
-        </p:nvSpPr>
-        <p:spPr>
-          <a:xfrm>
-            <a:off x="6583680" y="4206240"/>
-            <a:ext cx="4754880" cy="1737360"/>
-          </a:xfrm>
-          <a:prstGeom prst="rect">
-            <a:avLst/>
-          </a:prstGeom>
-          <a:noFill/>
-          <a:ln/>
-        </p:spPr>
-        <p:txBody>
-          <a:bodyPr wrap="square" rtlCol="0" anchor="ctr"/>
-          <a:lstStyle/>
-          <a:p>
-            <a:pPr indent="0" marL="0">
-              <a:lnSpc>
-                <a:spcPts val="1800"/>
-              </a:lnSpc>
-              <a:buNone/>
-            </a:pPr>
-            <a:r>
-              <a:rPr lang="en-US" sz="1600" b="1" dirty="0">
-                <a:solidFill>
-                  <a:srgbClr val="0F172A"/>
-                </a:solidFill>
-                <a:latin typeface="Microsoft YaHei" pitchFamily="34" charset="0"/>
-                <a:ea typeface="Microsoft YaHei" pitchFamily="34" charset="-122"/>
-                <a:cs typeface="Microsoft YaHei" pitchFamily="34" charset="-120"/>
-              </a:rPr>
-              <a:t>📋 Standard (操作规范度 - 权重 15%)
-</a:t>
-            </a:r>
-            <a:pPr indent="0" marL="0">
-              <a:lnSpc>
-                <a:spcPts val="1800"/>
-              </a:lnSpc>
-              <a:buNone/>
-            </a:pPr>
-            <a:r>
-              <a:rPr lang="en-US" sz="1250" dirty="0">
-                <a:solidFill>
-                  <a:srgbClr val="475569"/>
-                </a:solidFill>
-                <a:latin typeface="Microsoft YaHei" pitchFamily="34" charset="0"/>
-                <a:ea typeface="Microsoft YaHei" pitchFamily="34" charset="-122"/>
-                <a:cs typeface="Microsoft YaHei" pitchFamily="34" charset="-120"/>
-              </a:rPr>
-              <a:t>全面监控输入的语法错误、冗余指令和无意义获取。以极其严谨的标准规范日常操作作风，培养高水平 SRE 极客底色。</a:t>
-            </a:r>
-            <a:endParaRPr lang="en-US" sz="1250" dirty="0"/>
+              <a:t>状态机扭转、快照裁剪算法、危险字符过滤、资金预算扣除等，质量达到了极高标准。</a:t>
+            </a:r>
+            <a:endParaRPr lang="en-US" sz="1200" dirty="0"/>
           </a:p>
         </p:txBody>
       </p:sp>
@@ -5863,7 +6010,7 @@
                 <a:ea typeface="Microsoft YaHei" pitchFamily="34" charset="-122"/>
                 <a:cs typeface="Microsoft YaHei" pitchFamily="34" charset="-120"/>
               </a:rPr>
-              <a:t>7. 实验成果与测试验证</a:t>
+              <a:t>7. 总结收获与未来展望</a:t>
             </a:r>
             <a:endParaRPr lang="en-US" sz="2600" dirty="0"/>
           </a:p>
@@ -5902,7 +6049,7 @@
                 <a:ea typeface="Microsoft YaHei" pitchFamily="34" charset="-122"/>
                 <a:cs typeface="Microsoft YaHei" pitchFamily="34" charset="-120"/>
               </a:rPr>
-              <a:t>EXPERIMENTAL OUTCOMES &amp; VERIFICATION</a:t>
+              <a:t>SUMMARY, INSIGHTS &amp; FUTURE OUTLOOK</a:t>
             </a:r>
             <a:endParaRPr lang="en-US" sz="1200" dirty="0"/>
           </a:p>
@@ -6028,7 +6175,7 @@
                 <a:ea typeface="Microsoft YaHei" pitchFamily="34" charset="-122"/>
                 <a:cs typeface="Microsoft YaHei" pitchFamily="34" charset="-120"/>
               </a:rPr>
-              <a:t>🚀 物理靶场真实注入实测
+              <a:t>🌟 核心收获与心得体会
 </a:t>
             </a:r>
             <a:pPr indent="0" marL="0">
@@ -6046,7 +6193,24 @@
                 <a:ea typeface="Microsoft YaHei" pitchFamily="34" charset="-122"/>
                 <a:cs typeface="Microsoft YaHei" pitchFamily="34" charset="-120"/>
               </a:rPr>
-              <a:t>• 简单模式 (Easy Mode)：
+              <a:t>• 深化云原生弹性设计思维：</a:t>
+            </a:r>
+            <a:pPr indent="0" marL="0">
+              <a:lnSpc>
+                <a:spcPts val="1600"/>
+              </a:lnSpc>
+              <a:buNone/>
+            </a:pPr>
+            <a:r>
+              <a:rPr lang="en-US" sz="1250" dirty="0">
+                <a:solidFill>
+                  <a:srgbClr val="475569"/>
+                </a:solidFill>
+                <a:latin typeface="Microsoft YaHei" pitchFamily="34" charset="0"/>
+                <a:ea typeface="Microsoft YaHei" pitchFamily="34" charset="-122"/>
+                <a:cs typeface="Microsoft YaHei" pitchFamily="34" charset="-120"/>
+              </a:rPr>
+              <a:t>“Design for Failure”（面向故障设计）是云计算高可用架构的核心原则。通过混沌工程的主动破坏，切实感受到就绪探针、重启策略和自愈环对服务韧性的巨大保障。
 </a:t>
             </a:r>
             <a:pPr indent="0" marL="0">
@@ -6056,6 +6220,23 @@
               <a:buNone/>
             </a:pPr>
             <a:r>
+              <a:rPr lang="en-US" sz="1250" b="1" dirty="0">
+                <a:solidFill>
+                  <a:srgbClr val="0F172A"/>
+                </a:solidFill>
+                <a:latin typeface="Microsoft YaHei" pitchFamily="34" charset="0"/>
+                <a:ea typeface="Microsoft YaHei" pitchFamily="34" charset="-122"/>
+                <a:cs typeface="Microsoft YaHei" pitchFamily="34" charset="-120"/>
+              </a:rPr>
+              <a:t>• 掌握大模型云端落地范式：</a:t>
+            </a:r>
+            <a:pPr indent="0" marL="0">
+              <a:lnSpc>
+                <a:spcPts val="1600"/>
+              </a:lnSpc>
+              <a:buNone/>
+            </a:pPr>
+            <a:r>
               <a:rPr lang="en-US" sz="1250" dirty="0">
                 <a:solidFill>
                   <a:srgbClr val="475569"/>
@@ -6064,7 +6245,7 @@
                 <a:ea typeface="Microsoft YaHei" pitchFamily="34" charset="-122"/>
                 <a:cs typeface="Microsoft YaHei" pitchFamily="34" charset="-120"/>
               </a:rPr>
-              <a:t>  - 注入 order-service 磁盘满故障，产生 64MB 临时大文件。
+              <a:t>在 SRE 真实场景中，利用基线差异剪枝实现 75% 裁剪，是防止大模型幻觉与偏航的底层基石。
 </a:t>
             </a:r>
             <a:pPr indent="0" marL="0">
@@ -6074,6 +6255,23 @@
               <a:buNone/>
             </a:pPr>
             <a:r>
+              <a:rPr lang="en-US" sz="1250" b="1" dirty="0">
+                <a:solidFill>
+                  <a:srgbClr val="0F172A"/>
+                </a:solidFill>
+                <a:latin typeface="Microsoft YaHei" pitchFamily="34" charset="0"/>
+                <a:ea typeface="Microsoft YaHei" pitchFamily="34" charset="-122"/>
+                <a:cs typeface="Microsoft YaHei" pitchFamily="34" charset="-120"/>
+              </a:rPr>
+              <a:t>• 见证人机协同巨大潜力：</a:t>
+            </a:r>
+            <a:pPr indent="0" marL="0">
+              <a:lnSpc>
+                <a:spcPts val="1600"/>
+              </a:lnSpc>
+              <a:buNone/>
+            </a:pPr>
+            <a:r>
               <a:rPr lang="en-US" sz="1250" dirty="0">
                 <a:solidFill>
                   <a:srgbClr val="475569"/>
@@ -6082,61 +6280,7 @@
                 <a:ea typeface="Microsoft YaHei" pitchFamily="34" charset="-122"/>
                 <a:cs typeface="Microsoft YaHei" pitchFamily="34" charset="-120"/>
               </a:rPr>
-              <a:t>  - 人类利用终端精准捕获大文件路径并极速删除，集群立即无感自愈。
-</a:t>
-            </a:r>
-            <a:pPr indent="0" marL="0">
-              <a:lnSpc>
-                <a:spcPts val="1600"/>
-              </a:lnSpc>
-              <a:buNone/>
-            </a:pPr>
-            <a:r>
-              <a:rPr lang="en-US" sz="1250" b="1" dirty="0">
-                <a:solidFill>
-                  <a:srgbClr val="0F172A"/>
-                </a:solidFill>
-                <a:latin typeface="Microsoft YaHei" pitchFamily="34" charset="0"/>
-                <a:ea typeface="Microsoft YaHei" pitchFamily="34" charset="-122"/>
-                <a:cs typeface="Microsoft YaHei" pitchFamily="34" charset="-120"/>
-              </a:rPr>
-              <a:t>• 困难模式 (Hard Mode)：
-</a:t>
-            </a:r>
-            <a:pPr indent="0" marL="0">
-              <a:lnSpc>
-                <a:spcPts val="1600"/>
-              </a:lnSpc>
-              <a:buNone/>
-            </a:pPr>
-            <a:r>
-              <a:rPr lang="en-US" sz="1250" dirty="0">
-                <a:solidFill>
-                  <a:srgbClr val="475569"/>
-                </a:solidFill>
-                <a:latin typeface="Microsoft YaHei" pitchFamily="34" charset="0"/>
-                <a:ea typeface="Microsoft YaHei" pitchFamily="34" charset="-122"/>
-                <a:cs typeface="Microsoft YaHei" pitchFamily="34" charset="-120"/>
-              </a:rPr>
-              <a:t>  - 并发注入 product-service 缩零与 order-service PID 1 终结崩溃。
-</a:t>
-            </a:r>
-            <a:pPr indent="0" marL="0">
-              <a:lnSpc>
-                <a:spcPts val="1600"/>
-              </a:lnSpc>
-              <a:buNone/>
-            </a:pPr>
-            <a:r>
-              <a:rPr lang="en-US" sz="1250" dirty="0">
-                <a:solidFill>
-                  <a:srgbClr val="475569"/>
-                </a:solidFill>
-                <a:latin typeface="Microsoft YaHei" pitchFamily="34" charset="0"/>
-                <a:ea typeface="Microsoft YaHei" pitchFamily="34" charset="-122"/>
-                <a:cs typeface="Microsoft YaHei" pitchFamily="34" charset="-120"/>
-              </a:rPr>
-              <a:t>  - AI 利用 OODA 基线差异分析，20 秒内推荐并下发 `kubectl scale` 重构 product-service，展现了卓越的自动化应急响应力。</a:t>
+              <a:t>AI 在结构化状态判断与经典自愈指令执行上具备极速的优势，展现了强大的 AIOps 潜能。</a:t>
             </a:r>
             <a:endParaRPr lang="en-US" sz="1250" dirty="0"/>
           </a:p>
@@ -6190,30 +6334,30 @@
           <a:p>
             <a:pPr indent="0" marL="0">
               <a:lnSpc>
-                <a:spcPts val="1400"/>
+                <a:spcPts val="1600"/>
               </a:lnSpc>
               <a:buNone/>
             </a:pPr>
             <a:r>
               <a:rPr lang="en-US" sz="1800" b="1" dirty="0">
                 <a:solidFill>
-                  <a:srgbClr val="10B981"/>
-                </a:solidFill>
-                <a:latin typeface="Microsoft YaHei" pitchFamily="34" charset="0"/>
-                <a:ea typeface="Microsoft YaHei" pitchFamily="34" charset="-122"/>
-                <a:cs typeface="Microsoft YaHei" pitchFamily="34" charset="-120"/>
-              </a:rPr>
-              <a:t>🧪 健全的自动化测试组件
+                  <a:srgbClr val="EA580C"/>
+                </a:solidFill>
+                <a:latin typeface="Microsoft YaHei" pitchFamily="34" charset="0"/>
+                <a:ea typeface="Microsoft YaHei" pitchFamily="34" charset="-122"/>
+                <a:cs typeface="Microsoft YaHei" pitchFamily="34" charset="-120"/>
+              </a:rPr>
+              <a:t>🚀 未来演进方向
 </a:t>
             </a:r>
             <a:pPr indent="0" marL="0">
               <a:lnSpc>
-                <a:spcPts val="1400"/>
-              </a:lnSpc>
-              <a:buNone/>
-            </a:pPr>
-            <a:r>
-              <a:rPr lang="en-US" sz="1200" b="1" dirty="0">
+                <a:spcPts val="1600"/>
+              </a:lnSpc>
+              <a:buNone/>
+            </a:pPr>
+            <a:r>
+              <a:rPr lang="en-US" sz="1250" b="1" dirty="0">
                 <a:solidFill>
                   <a:srgbClr val="0F172A"/>
                 </a:solidFill>
@@ -6221,107 +6365,69 @@
                 <a:ea typeface="Microsoft YaHei" pitchFamily="34" charset="-122"/>
                 <a:cs typeface="Microsoft YaHei" pitchFamily="34" charset="-120"/>
               </a:rPr>
-              <a:t>项目引入了基于 Jest 框架的工业级自动化测试覆盖：
+              <a:t>• 融入细粒度全链路可观测性指标：</a:t>
+            </a:r>
+            <a:pPr indent="0" marL="0">
+              <a:lnSpc>
+                <a:spcPts val="1600"/>
+              </a:lnSpc>
+              <a:buNone/>
+            </a:pPr>
+            <a:r>
+              <a:rPr lang="en-US" sz="1250" dirty="0">
+                <a:solidFill>
+                  <a:srgbClr val="475569"/>
+                </a:solidFill>
+                <a:latin typeface="Microsoft YaHei" pitchFamily="34" charset="0"/>
+                <a:ea typeface="Microsoft YaHei" pitchFamily="34" charset="-122"/>
+                <a:cs typeface="Microsoft YaHei" pitchFamily="34" charset="-120"/>
+              </a:rPr>
+              <a:t>拟进一步集成 Prometheus 与 OpenTelemetry，将系统时序指标以图谱的形式喂入大模型，支持精准性能调优决策。
 </a:t>
             </a:r>
             <a:pPr indent="0" marL="0">
               <a:lnSpc>
-                <a:spcPts val="1400"/>
-              </a:lnSpc>
-              <a:buNone/>
-            </a:pPr>
-            <a:r>
-              <a:rPr lang="en-US" sz="1200" dirty="0">
-                <a:solidFill>
-                  <a:srgbClr val="10B981"/>
-                </a:solidFill>
-                <a:latin typeface="Microsoft YaHei" pitchFamily="34" charset="0"/>
-                <a:ea typeface="Microsoft YaHei" pitchFamily="34" charset="-122"/>
-                <a:cs typeface="Microsoft YaHei" pitchFamily="34" charset="-120"/>
-              </a:rPr>
-              <a:t>✔ PASS  __tests__/scorer.test.js
+                <a:spcPts val="1600"/>
+              </a:lnSpc>
+              <a:buNone/>
+            </a:pPr>
+            <a:r>
+              <a:rPr lang="en-US" sz="1250" b="1" dirty="0">
+                <a:solidFill>
+                  <a:srgbClr val="0F172A"/>
+                </a:solidFill>
+                <a:latin typeface="Microsoft YaHei" pitchFamily="34" charset="0"/>
+                <a:ea typeface="Microsoft YaHei" pitchFamily="34" charset="-122"/>
+                <a:cs typeface="Microsoft YaHei" pitchFamily="34" charset="-120"/>
+              </a:rPr>
+              <a:t>• 智能体左右互搏对抗：</a:t>
+            </a:r>
+            <a:pPr indent="0" marL="0">
+              <a:lnSpc>
+                <a:spcPts val="1600"/>
+              </a:lnSpc>
+              <a:buNone/>
+            </a:pPr>
+            <a:r>
+              <a:rPr lang="en-US" sz="1250" dirty="0">
+                <a:solidFill>
+                  <a:srgbClr val="475569"/>
+                </a:solidFill>
+                <a:latin typeface="Microsoft YaHei" pitchFamily="34" charset="0"/>
+                <a:ea typeface="Microsoft YaHei" pitchFamily="34" charset="-122"/>
+                <a:cs typeface="Microsoft YaHei" pitchFamily="34" charset="-120"/>
+              </a:rPr>
+              <a:t>构建一边主动注入多样故障，另一边实时监控修复的“双智能体自进化对抗沙箱”，持续寻找微服务弹性的极限边界。
 </a:t>
             </a:r>
             <a:pPr indent="0" marL="0">
               <a:lnSpc>
-                <a:spcPts val="1400"/>
-              </a:lnSpc>
-              <a:buNone/>
-            </a:pPr>
-            <a:r>
-              <a:rPr lang="en-US" sz="1200" dirty="0">
-                <a:solidFill>
-                  <a:srgbClr val="10B981"/>
-                </a:solidFill>
-                <a:latin typeface="Microsoft YaHei" pitchFamily="34" charset="0"/>
-                <a:ea typeface="Microsoft YaHei" pitchFamily="34" charset="-122"/>
-                <a:cs typeface="Microsoft YaHei" pitchFamily="34" charset="-120"/>
-              </a:rPr>
-              <a:t>✔ PASS  __tests__/chaos-injector.test.js
-</a:t>
-            </a:r>
-            <a:pPr indent="0" marL="0">
-              <a:lnSpc>
-                <a:spcPts val="1400"/>
-              </a:lnSpc>
-              <a:buNone/>
-            </a:pPr>
-            <a:r>
-              <a:rPr lang="en-US" sz="1200" dirty="0">
-                <a:solidFill>
-                  <a:srgbClr val="10B981"/>
-                </a:solidFill>
-                <a:latin typeface="Microsoft YaHei" pitchFamily="34" charset="0"/>
-                <a:ea typeface="Microsoft YaHei" pitchFamily="34" charset="-122"/>
-                <a:cs typeface="Microsoft YaHei" pitchFamily="34" charset="-120"/>
-              </a:rPr>
-              <a:t>✔ PASS  __tests__/terminal-proxy.test.js
-</a:t>
-            </a:r>
-            <a:pPr indent="0" marL="0">
-              <a:lnSpc>
-                <a:spcPts val="1400"/>
-              </a:lnSpc>
-              <a:buNone/>
-            </a:pPr>
-            <a:r>
-              <a:rPr lang="en-US" sz="1200" dirty="0">
-                <a:solidFill>
-                  <a:srgbClr val="10B981"/>
-                </a:solidFill>
-                <a:latin typeface="Microsoft YaHei" pitchFamily="34" charset="0"/>
-                <a:ea typeface="Microsoft YaHei" pitchFamily="34" charset="-122"/>
-                <a:cs typeface="Microsoft YaHei" pitchFamily="34" charset="-120"/>
-              </a:rPr>
-              <a:t>✔ PASS  __tests__/ai-engine.test.js
-</a:t>
-            </a:r>
-            <a:pPr indent="0" marL="0">
-              <a:lnSpc>
-                <a:spcPts val="1400"/>
-              </a:lnSpc>
-              <a:buNone/>
-            </a:pPr>
-            <a:r>
-              <a:rPr lang="en-US" sz="1200" dirty="0">
-                <a:solidFill>
-                  <a:srgbClr val="10B981"/>
-                </a:solidFill>
-                <a:latin typeface="Microsoft YaHei" pitchFamily="34" charset="0"/>
-                <a:ea typeface="Microsoft YaHei" pitchFamily="34" charset="-122"/>
-                <a:cs typeface="Microsoft YaHei" pitchFamily="34" charset="-120"/>
-              </a:rPr>
-              <a:t>✔ PASS  __tests__/integration.test.js
-</a:t>
-            </a:r>
-            <a:pPr indent="0" marL="0">
-              <a:lnSpc>
-                <a:spcPts val="1400"/>
-              </a:lnSpc>
-              <a:buNone/>
-            </a:pPr>
-            <a:r>
-              <a:rPr lang="en-US" sz="1200" b="1" dirty="0">
+                <a:spcPts val="1600"/>
+              </a:lnSpc>
+              <a:buNone/>
+            </a:pPr>
+            <a:r>
+              <a:rPr lang="en-US" sz="1250" b="1" dirty="0">
                 <a:solidFill>
                   <a:srgbClr val="0F172A"/>
                 </a:solidFill>
@@ -6329,16 +6435,16 @@
                 <a:ea typeface="Microsoft YaHei" pitchFamily="34" charset="-122"/>
                 <a:cs typeface="Microsoft YaHei" pitchFamily="34" charset="-120"/>
               </a:rPr>
-              <a:t>• 累计通过：</a:t>
-            </a:r>
-            <a:pPr indent="0" marL="0">
-              <a:lnSpc>
-                <a:spcPts val="1400"/>
-              </a:lnSpc>
-              <a:buNone/>
-            </a:pPr>
-            <a:r>
-              <a:rPr lang="en-US" sz="1200" dirty="0">
+              <a:t>• 分布式多集群消防演练：</a:t>
+            </a:r>
+            <a:pPr indent="0" marL="0">
+              <a:lnSpc>
+                <a:spcPts val="1600"/>
+              </a:lnSpc>
+              <a:buNone/>
+            </a:pPr>
+            <a:r>
+              <a:rPr lang="en-US" sz="1250" dirty="0">
                 <a:solidFill>
                   <a:srgbClr val="475569"/>
                 </a:solidFill>
@@ -6346,44 +6452,9 @@
                 <a:ea typeface="Microsoft YaHei" pitchFamily="34" charset="-122"/>
                 <a:cs typeface="Microsoft YaHei" pitchFamily="34" charset="-120"/>
               </a:rPr>
-              <a:t>108 个底层核心单元/集成测试用例。
-</a:t>
-            </a:r>
-            <a:pPr indent="0" marL="0">
-              <a:lnSpc>
-                <a:spcPts val="1400"/>
-              </a:lnSpc>
-              <a:buNone/>
-            </a:pPr>
-            <a:r>
-              <a:rPr lang="en-US" sz="1200" b="1" dirty="0">
-                <a:solidFill>
-                  <a:srgbClr val="0F172A"/>
-                </a:solidFill>
-                <a:latin typeface="Microsoft YaHei" pitchFamily="34" charset="0"/>
-                <a:ea typeface="Microsoft YaHei" pitchFamily="34" charset="-122"/>
-                <a:cs typeface="Microsoft YaHei" pitchFamily="34" charset="-120"/>
-              </a:rPr>
-              <a:t>• 高抗覆盖：</a:t>
-            </a:r>
-            <a:pPr indent="0" marL="0">
-              <a:lnSpc>
-                <a:spcPts val="1400"/>
-              </a:lnSpc>
-              <a:buNone/>
-            </a:pPr>
-            <a:r>
-              <a:rPr lang="en-US" sz="1200" dirty="0">
-                <a:solidFill>
-                  <a:srgbClr val="475569"/>
-                </a:solidFill>
-                <a:latin typeface="Microsoft YaHei" pitchFamily="34" charset="0"/>
-                <a:ea typeface="Microsoft YaHei" pitchFamily="34" charset="-122"/>
-                <a:cs typeface="Microsoft YaHei" pitchFamily="34" charset="-120"/>
-              </a:rPr>
-              <a:t>状态机扭转、快照裁剪算法、危险字符过滤、资金预算扣除等，质量达到了极高标准。</a:t>
-            </a:r>
-            <a:endParaRPr lang="en-US" sz="1200" dirty="0"/>
+              <a:t>拟将单集群扩展为多云混合异构分布式靶场，实现跨广域网络雪崩环境的超大规模混沌演练。</a:t>
+            </a:r>
+            <a:endParaRPr lang="en-US" sz="1250" dirty="0"/>
           </a:p>
         </p:txBody>
       </p:sp>
@@ -6427,8 +6498,8 @@
         </p:nvSpPr>
         <p:spPr>
           <a:xfrm>
-            <a:off x="0" y="0"/>
-            <a:ext cx="12188952" cy="91440"/>
+            <a:off x="0" y="3291840"/>
+            <a:ext cx="12188952" cy="274320"/>
           </a:xfrm>
           <a:prstGeom prst="rect">
             <a:avLst/>
@@ -6447,8 +6518,8 @@
         </p:nvSpPr>
         <p:spPr>
           <a:xfrm>
-            <a:off x="548640" y="365760"/>
-            <a:ext cx="10972800" cy="548640"/>
+            <a:off x="914400" y="1828800"/>
+            <a:ext cx="10360152" cy="914400"/>
           </a:xfrm>
           <a:prstGeom prst="rect">
             <a:avLst/>
@@ -6460,11 +6531,50 @@
           <a:bodyPr wrap="square" rtlCol="0" anchor="ctr"/>
           <a:lstStyle/>
           <a:p>
-            <a:pPr indent="0" marL="0">
-              <a:buNone/>
-            </a:pPr>
-            <a:r>
-              <a:rPr lang="en-US" sz="2600" b="1" dirty="0">
+            <a:pPr algn="ctr" indent="0" marL="0">
+              <a:buNone/>
+            </a:pPr>
+            <a:r>
+              <a:rPr lang="en-US" sz="5400" b="1" dirty="0">
+                <a:solidFill>
+                  <a:srgbClr val="0284C7"/>
+                </a:solidFill>
+                <a:latin typeface="Trebuchet MS" pitchFamily="34" charset="0"/>
+                <a:ea typeface="Trebuchet MS" pitchFamily="34" charset="-122"/>
+                <a:cs typeface="Trebuchet MS" pitchFamily="34" charset="-120"/>
+              </a:rPr>
+              <a:t>THANK YOU</a:t>
+            </a:r>
+            <a:endParaRPr lang="en-US" sz="5400" dirty="0"/>
+          </a:p>
+        </p:txBody>
+      </p:sp>
+      <p:sp>
+        <p:nvSpPr>
+          <p:cNvPr id="4" name="Text 2"/>
+          <p:cNvSpPr/>
+          <p:nvPr/>
+        </p:nvSpPr>
+        <p:spPr>
+          <a:xfrm>
+            <a:off x="914400" y="3840480"/>
+            <a:ext cx="10360152" cy="731520"/>
+          </a:xfrm>
+          <a:prstGeom prst="rect">
+            <a:avLst/>
+          </a:prstGeom>
+          <a:noFill/>
+          <a:ln/>
+        </p:spPr>
+        <p:txBody>
+          <a:bodyPr wrap="square" rtlCol="0" anchor="ctr"/>
+          <a:lstStyle/>
+          <a:p>
+            <a:pPr algn="ctr" indent="0" marL="0">
+              <a:buNone/>
+            </a:pPr>
+            <a:r>
+              <a:rPr lang="en-US" sz="2400" b="1" dirty="0">
                 <a:solidFill>
                   <a:srgbClr val="0F172A"/>
                 </a:solidFill>
@@ -6472,22 +6582,22 @@
                 <a:ea typeface="Microsoft YaHei" pitchFamily="34" charset="-122"/>
                 <a:cs typeface="Microsoft YaHei" pitchFamily="34" charset="-120"/>
               </a:rPr>
-              <a:t>8. 总结、收获与未来展望</a:t>
-            </a:r>
-            <a:endParaRPr lang="en-US" sz="2600" dirty="0"/>
-          </a:p>
-        </p:txBody>
-      </p:sp>
-      <p:sp>
-        <p:nvSpPr>
-          <p:cNvPr id="4" name="Text 2"/>
-          <p:cNvSpPr/>
-          <p:nvPr/>
-        </p:nvSpPr>
-        <p:spPr>
-          <a:xfrm>
-            <a:off x="548640" y="868680"/>
-            <a:ext cx="10972800" cy="274320"/>
+              <a:t>敬请各位老师、专家批评指正！</a:t>
+            </a:r>
+            <a:endParaRPr lang="en-US" sz="2400" dirty="0"/>
+          </a:p>
+        </p:txBody>
+      </p:sp>
+      <p:sp>
+        <p:nvSpPr>
+          <p:cNvPr id="5" name="Text 3"/>
+          <p:cNvSpPr/>
+          <p:nvPr/>
+        </p:nvSpPr>
+        <p:spPr>
+          <a:xfrm>
+            <a:off x="914400" y="4754880"/>
+            <a:ext cx="10360152" cy="548640"/>
           </a:xfrm>
           <a:prstGeom prst="rect">
             <a:avLst/>
@@ -6499,70 +6609,11 @@
           <a:bodyPr wrap="square" rtlCol="0" anchor="ctr"/>
           <a:lstStyle/>
           <a:p>
-            <a:pPr indent="0" marL="0">
-              <a:buNone/>
-            </a:pPr>
-            <a:r>
-              <a:rPr lang="en-US" sz="1200" i="1" dirty="0">
-                <a:solidFill>
-                  <a:srgbClr val="0284C7"/>
-                </a:solidFill>
-                <a:latin typeface="Microsoft YaHei" pitchFamily="34" charset="0"/>
-                <a:ea typeface="Microsoft YaHei" pitchFamily="34" charset="-122"/>
-                <a:cs typeface="Microsoft YaHei" pitchFamily="34" charset="-120"/>
-              </a:rPr>
-              <a:t>SUMMARY, INSIGHTS &amp; FUTURE OUTLOOK</a:t>
-            </a:r>
-            <a:endParaRPr lang="en-US" sz="1200" dirty="0"/>
-          </a:p>
-        </p:txBody>
-      </p:sp>
-      <p:sp>
-        <p:nvSpPr>
-          <p:cNvPr id="5" name="Shape 3"/>
-          <p:cNvSpPr/>
-          <p:nvPr/>
-        </p:nvSpPr>
-        <p:spPr>
-          <a:xfrm>
-            <a:off x="548640" y="1188720"/>
-            <a:ext cx="11091672" cy="18288"/>
-          </a:xfrm>
-          <a:prstGeom prst="rect">
-            <a:avLst/>
-          </a:prstGeom>
-          <a:solidFill>
-            <a:srgbClr val="CBD5E1"/>
-          </a:solidFill>
-          <a:ln/>
-        </p:spPr>
-      </p:sp>
-      <p:sp>
-        <p:nvSpPr>
-          <p:cNvPr id="6" name="Text 4"/>
-          <p:cNvSpPr/>
-          <p:nvPr/>
-        </p:nvSpPr>
-        <p:spPr>
-          <a:xfrm>
-            <a:off x="548640" y="6492240"/>
-            <a:ext cx="5486400" cy="274320"/>
-          </a:xfrm>
-          <a:prstGeom prst="rect">
-            <a:avLst/>
-          </a:prstGeom>
-          <a:noFill/>
-          <a:ln/>
-        </p:spPr>
-        <p:txBody>
-          <a:bodyPr wrap="square" rtlCol="0" anchor="ctr"/>
-          <a:lstStyle/>
-          <a:p>
-            <a:pPr indent="0" marL="0">
-              <a:buNone/>
-            </a:pPr>
-            <a:r>
-              <a:rPr lang="en-US" sz="1000" dirty="0">
+            <a:pPr algn="ctr" indent="0" marL="0">
+              <a:buNone/>
+            </a:pPr>
+            <a:r>
+              <a:rPr lang="en-US" sz="1400" dirty="0">
                 <a:solidFill>
                   <a:srgbClr val="475569"/>
                 </a:solidFill>
@@ -6570,353 +6621,9 @@
                 <a:ea typeface="Microsoft YaHei" pitchFamily="34" charset="-122"/>
                 <a:cs typeface="Microsoft YaHei" pitchFamily="34" charset="-120"/>
               </a:rPr>
-              <a:t>Chaos Fire Drill | 期末大项目汇报答辩</a:t>
-            </a:r>
-            <a:endParaRPr lang="en-US" sz="1000" dirty="0"/>
-          </a:p>
-        </p:txBody>
-      </p:sp>
-      <p:sp>
-        <p:nvSpPr>
-          <p:cNvPr id="7" name="Shape 5"/>
-          <p:cNvSpPr/>
-          <p:nvPr/>
-        </p:nvSpPr>
-        <p:spPr>
-          <a:xfrm>
-            <a:off x="548640" y="1463040"/>
-            <a:ext cx="5303520" cy="4663440"/>
-          </a:xfrm>
-          <a:prstGeom prst="roundRect">
-            <a:avLst/>
-          </a:prstGeom>
-          <a:solidFill>
-            <a:srgbClr val="FFFFFF"/>
-          </a:solidFill>
-          <a:ln w="12700">
-            <a:solidFill>
-              <a:srgbClr val="E2E8F0"/>
-            </a:solidFill>
-            <a:prstDash val="solid"/>
-          </a:ln>
-        </p:spPr>
-      </p:sp>
-      <p:sp>
-        <p:nvSpPr>
-          <p:cNvPr id="8" name="Text 6"/>
-          <p:cNvSpPr/>
-          <p:nvPr/>
-        </p:nvSpPr>
-        <p:spPr>
-          <a:xfrm>
-            <a:off x="822960" y="1645920"/>
-            <a:ext cx="4754880" cy="4297680"/>
-          </a:xfrm>
-          <a:prstGeom prst="rect">
-            <a:avLst/>
-          </a:prstGeom>
-          <a:noFill/>
-          <a:ln/>
-        </p:spPr>
-        <p:txBody>
-          <a:bodyPr wrap="square" rtlCol="0" anchor="ctr"/>
-          <a:lstStyle/>
-          <a:p>
-            <a:pPr indent="0" marL="0">
-              <a:lnSpc>
-                <a:spcPts val="1600"/>
-              </a:lnSpc>
-              <a:buNone/>
-            </a:pPr>
-            <a:r>
-              <a:rPr lang="en-US" sz="1800" b="1" dirty="0">
-                <a:solidFill>
-                  <a:srgbClr val="0284C7"/>
-                </a:solidFill>
-                <a:latin typeface="Microsoft YaHei" pitchFamily="34" charset="0"/>
-                <a:ea typeface="Microsoft YaHei" pitchFamily="34" charset="-122"/>
-                <a:cs typeface="Microsoft YaHei" pitchFamily="34" charset="-120"/>
-              </a:rPr>
-              <a:t>🌟 核心收获与心得体会
-</a:t>
-            </a:r>
-            <a:pPr indent="0" marL="0">
-              <a:lnSpc>
-                <a:spcPts val="1600"/>
-              </a:lnSpc>
-              <a:buNone/>
-            </a:pPr>
-            <a:r>
-              <a:rPr lang="en-US" sz="1250" b="1" dirty="0">
-                <a:solidFill>
-                  <a:srgbClr val="0F172A"/>
-                </a:solidFill>
-                <a:latin typeface="Microsoft YaHei" pitchFamily="34" charset="0"/>
-                <a:ea typeface="Microsoft YaHei" pitchFamily="34" charset="-122"/>
-                <a:cs typeface="Microsoft YaHei" pitchFamily="34" charset="-120"/>
-              </a:rPr>
-              <a:t>• 深化云原生弹性设计思维：</a:t>
-            </a:r>
-            <a:pPr indent="0" marL="0">
-              <a:lnSpc>
-                <a:spcPts val="1600"/>
-              </a:lnSpc>
-              <a:buNone/>
-            </a:pPr>
-            <a:r>
-              <a:rPr lang="en-US" sz="1250" dirty="0">
-                <a:solidFill>
-                  <a:srgbClr val="475569"/>
-                </a:solidFill>
-                <a:latin typeface="Microsoft YaHei" pitchFamily="34" charset="0"/>
-                <a:ea typeface="Microsoft YaHei" pitchFamily="34" charset="-122"/>
-                <a:cs typeface="Microsoft YaHei" pitchFamily="34" charset="-120"/>
-              </a:rPr>
-              <a:t>“Design for Failure”（面向故障设计）是云计算高可用架构的核心原则。通过混沌工程的主动破坏，切实感受到就绪探针、重启策略和自愈环对服务韧性的巨大保障。
-</a:t>
-            </a:r>
-            <a:pPr indent="0" marL="0">
-              <a:lnSpc>
-                <a:spcPts val="1600"/>
-              </a:lnSpc>
-              <a:buNone/>
-            </a:pPr>
-            <a:r>
-              <a:rPr lang="en-US" sz="1250" b="1" dirty="0">
-                <a:solidFill>
-                  <a:srgbClr val="0F172A"/>
-                </a:solidFill>
-                <a:latin typeface="Microsoft YaHei" pitchFamily="34" charset="0"/>
-                <a:ea typeface="Microsoft YaHei" pitchFamily="34" charset="-122"/>
-                <a:cs typeface="Microsoft YaHei" pitchFamily="34" charset="-120"/>
-              </a:rPr>
-              <a:t>• 掌握大模型云端落地范式：</a:t>
-            </a:r>
-            <a:pPr indent="0" marL="0">
-              <a:lnSpc>
-                <a:spcPts val="1600"/>
-              </a:lnSpc>
-              <a:buNone/>
-            </a:pPr>
-            <a:r>
-              <a:rPr lang="en-US" sz="1250" dirty="0">
-                <a:solidFill>
-                  <a:srgbClr val="475569"/>
-                </a:solidFill>
-                <a:latin typeface="Microsoft YaHei" pitchFamily="34" charset="0"/>
-                <a:ea typeface="Microsoft YaHei" pitchFamily="34" charset="-122"/>
-                <a:cs typeface="Microsoft YaHei" pitchFamily="34" charset="-120"/>
-              </a:rPr>
-              <a:t>在 SRE 真实场景中，利用基线差异剪枝实现 75% 裁剪，是防止大模型幻觉与偏航的底层基石。
-</a:t>
-            </a:r>
-            <a:pPr indent="0" marL="0">
-              <a:lnSpc>
-                <a:spcPts val="1600"/>
-              </a:lnSpc>
-              <a:buNone/>
-            </a:pPr>
-            <a:r>
-              <a:rPr lang="en-US" sz="1250" b="1" dirty="0">
-                <a:solidFill>
-                  <a:srgbClr val="0F172A"/>
-                </a:solidFill>
-                <a:latin typeface="Microsoft YaHei" pitchFamily="34" charset="0"/>
-                <a:ea typeface="Microsoft YaHei" pitchFamily="34" charset="-122"/>
-                <a:cs typeface="Microsoft YaHei" pitchFamily="34" charset="-120"/>
-              </a:rPr>
-              <a:t>• 见证人机协同巨大潜力：</a:t>
-            </a:r>
-            <a:pPr indent="0" marL="0">
-              <a:lnSpc>
-                <a:spcPts val="1600"/>
-              </a:lnSpc>
-              <a:buNone/>
-            </a:pPr>
-            <a:r>
-              <a:rPr lang="en-US" sz="1250" dirty="0">
-                <a:solidFill>
-                  <a:srgbClr val="475569"/>
-                </a:solidFill>
-                <a:latin typeface="Microsoft YaHei" pitchFamily="34" charset="0"/>
-                <a:ea typeface="Microsoft YaHei" pitchFamily="34" charset="-122"/>
-                <a:cs typeface="Microsoft YaHei" pitchFamily="34" charset="-120"/>
-              </a:rPr>
-              <a:t>AI 在结构化状态判断与经典自愈指令执行上具备极速的优势，展现了强大的 AIOps 潜能。</a:t>
-            </a:r>
-            <a:endParaRPr lang="en-US" sz="1250" dirty="0"/>
-          </a:p>
-        </p:txBody>
-      </p:sp>
-      <p:sp>
-        <p:nvSpPr>
-          <p:cNvPr id="9" name="Shape 7"/>
-          <p:cNvSpPr/>
-          <p:nvPr/>
-        </p:nvSpPr>
-        <p:spPr>
-          <a:xfrm>
-            <a:off x="6309360" y="1463040"/>
-            <a:ext cx="5303520" cy="4663440"/>
-          </a:xfrm>
-          <a:prstGeom prst="roundRect">
-            <a:avLst/>
-          </a:prstGeom>
-          <a:solidFill>
-            <a:srgbClr val="FFFFFF"/>
-          </a:solidFill>
-          <a:ln w="12700">
-            <a:solidFill>
-              <a:srgbClr val="E2E8F0"/>
-            </a:solidFill>
-            <a:prstDash val="solid"/>
-          </a:ln>
-        </p:spPr>
-      </p:sp>
-      <p:sp>
-        <p:nvSpPr>
-          <p:cNvPr id="10" name="Text 8"/>
-          <p:cNvSpPr/>
-          <p:nvPr/>
-        </p:nvSpPr>
-        <p:spPr>
-          <a:xfrm>
-            <a:off x="6583680" y="1645920"/>
-            <a:ext cx="4754880" cy="4297680"/>
-          </a:xfrm>
-          <a:prstGeom prst="rect">
-            <a:avLst/>
-          </a:prstGeom>
-          <a:noFill/>
-          <a:ln/>
-        </p:spPr>
-        <p:txBody>
-          <a:bodyPr wrap="square" rtlCol="0" anchor="ctr"/>
-          <a:lstStyle/>
-          <a:p>
-            <a:pPr indent="0" marL="0">
-              <a:lnSpc>
-                <a:spcPts val="1600"/>
-              </a:lnSpc>
-              <a:buNone/>
-            </a:pPr>
-            <a:r>
-              <a:rPr lang="en-US" sz="1800" b="1" dirty="0">
-                <a:solidFill>
-                  <a:srgbClr val="EA580C"/>
-                </a:solidFill>
-                <a:latin typeface="Microsoft YaHei" pitchFamily="34" charset="0"/>
-                <a:ea typeface="Microsoft YaHei" pitchFamily="34" charset="-122"/>
-                <a:cs typeface="Microsoft YaHei" pitchFamily="34" charset="-120"/>
-              </a:rPr>
-              <a:t>🚀 未来演进方向
-</a:t>
-            </a:r>
-            <a:pPr indent="0" marL="0">
-              <a:lnSpc>
-                <a:spcPts val="1600"/>
-              </a:lnSpc>
-              <a:buNone/>
-            </a:pPr>
-            <a:r>
-              <a:rPr lang="en-US" sz="1250" b="1" dirty="0">
-                <a:solidFill>
-                  <a:srgbClr val="0F172A"/>
-                </a:solidFill>
-                <a:latin typeface="Microsoft YaHei" pitchFamily="34" charset="0"/>
-                <a:ea typeface="Microsoft YaHei" pitchFamily="34" charset="-122"/>
-                <a:cs typeface="Microsoft YaHei" pitchFamily="34" charset="-120"/>
-              </a:rPr>
-              <a:t>• 融入细粒度全链路可观测性指标：</a:t>
-            </a:r>
-            <a:pPr indent="0" marL="0">
-              <a:lnSpc>
-                <a:spcPts val="1600"/>
-              </a:lnSpc>
-              <a:buNone/>
-            </a:pPr>
-            <a:r>
-              <a:rPr lang="en-US" sz="1250" dirty="0">
-                <a:solidFill>
-                  <a:srgbClr val="475569"/>
-                </a:solidFill>
-                <a:latin typeface="Microsoft YaHei" pitchFamily="34" charset="0"/>
-                <a:ea typeface="Microsoft YaHei" pitchFamily="34" charset="-122"/>
-                <a:cs typeface="Microsoft YaHei" pitchFamily="34" charset="-120"/>
-              </a:rPr>
-              <a:t>拟进一步集成 Prometheus 与 OpenTelemetry，将系统时序指标以图谱的形式喂入大模型，支持精准性能调优决策。
-</a:t>
-            </a:r>
-            <a:pPr indent="0" marL="0">
-              <a:lnSpc>
-                <a:spcPts val="1600"/>
-              </a:lnSpc>
-              <a:buNone/>
-            </a:pPr>
-            <a:r>
-              <a:rPr lang="en-US" sz="1250" b="1" dirty="0">
-                <a:solidFill>
-                  <a:srgbClr val="0F172A"/>
-                </a:solidFill>
-                <a:latin typeface="Microsoft YaHei" pitchFamily="34" charset="0"/>
-                <a:ea typeface="Microsoft YaHei" pitchFamily="34" charset="-122"/>
-                <a:cs typeface="Microsoft YaHei" pitchFamily="34" charset="-120"/>
-              </a:rPr>
-              <a:t>• 智能体左右互搏对抗：</a:t>
-            </a:r>
-            <a:pPr indent="0" marL="0">
-              <a:lnSpc>
-                <a:spcPts val="1600"/>
-              </a:lnSpc>
-              <a:buNone/>
-            </a:pPr>
-            <a:r>
-              <a:rPr lang="en-US" sz="1250" dirty="0">
-                <a:solidFill>
-                  <a:srgbClr val="475569"/>
-                </a:solidFill>
-                <a:latin typeface="Microsoft YaHei" pitchFamily="34" charset="0"/>
-                <a:ea typeface="Microsoft YaHei" pitchFamily="34" charset="-122"/>
-                <a:cs typeface="Microsoft YaHei" pitchFamily="34" charset="-120"/>
-              </a:rPr>
-              <a:t>构建一边主动注入多样故障，另一边实时监控修复的“双智能体自进化对抗沙箱”，持续寻找微服务弹性的极限边界。
-</a:t>
-            </a:r>
-            <a:pPr indent="0" marL="0">
-              <a:lnSpc>
-                <a:spcPts val="1600"/>
-              </a:lnSpc>
-              <a:buNone/>
-            </a:pPr>
-            <a:r>
-              <a:rPr lang="en-US" sz="1250" b="1" dirty="0">
-                <a:solidFill>
-                  <a:srgbClr val="0F172A"/>
-                </a:solidFill>
-                <a:latin typeface="Microsoft YaHei" pitchFamily="34" charset="0"/>
-                <a:ea typeface="Microsoft YaHei" pitchFamily="34" charset="-122"/>
-                <a:cs typeface="Microsoft YaHei" pitchFamily="34" charset="-120"/>
-              </a:rPr>
-              <a:t>• 分布式多集群消防演练：</a:t>
-            </a:r>
-            <a:pPr indent="0" marL="0">
-              <a:lnSpc>
-                <a:spcPts val="1600"/>
-              </a:lnSpc>
-              <a:buNone/>
-            </a:pPr>
-            <a:r>
-              <a:rPr lang="en-US" sz="1250" dirty="0">
-                <a:solidFill>
-                  <a:srgbClr val="475569"/>
-                </a:solidFill>
-                <a:latin typeface="Microsoft YaHei" pitchFamily="34" charset="0"/>
-                <a:ea typeface="Microsoft YaHei" pitchFamily="34" charset="-122"/>
-                <a:cs typeface="Microsoft YaHei" pitchFamily="34" charset="-120"/>
-              </a:rPr>
-              <a:t>拟将单集群扩展为多云混合异构分布式靶场，实现跨广域网络雪崩环境的超大规模混沌演练。</a:t>
-            </a:r>
-            <a:endParaRPr lang="en-US" sz="1250" dirty="0"/>
+              <a:t>Chaos Fire Drill 项目开发小组 | 云计算与微服务大作业答辩</a:t>
+            </a:r>
+            <a:endParaRPr lang="en-US" sz="1400" dirty="0"/>
           </a:p>
         </p:txBody>
       </p:sp>

</xml_diff>